<commit_message>
Separa módulos YANG de capacidades de protocolo e torna o demo robusto a frio
A lista de capacidades anunciada por um elemento NETCONF mistura os módulos
YANG que ele suporta com as capacidades do próprio protocolo (candidate,
validate, xpath e afins). O inventário tratava tudo como módulo YANG, o que
inflava a contagem e enchia os chips com URNs de protocolo truncadas.

Agora as duas classes são separadas na leitura do controlador: os elementos
anunciam 33 (O-DU) e 84 (O-RU) módulos YANG, mais 13 capacidades de protocolo
cada — antes reportados como 46 e 97. Relatório, apresentação e scripts foram
corrigidos com os números certos.

Também ajustados após um teste de subida a frio com volumes removidos:

- demo.sh espera ativamente o Non-RT RIC sincronizar o tipo de política com o
  RIC, em vez de um sleep fixo que não bastava numa pilha recém-criada;
- mensagem final de up.sh não menciona mais o NETCONF Call Home, que esta
  implantação não usa.
</commit_message>
<xml_diff>
--- a/docs/Apresentacao_Parte2_SMO_OpenRAN.pptx
+++ b/docs/Apresentacao_Parte2_SMO_OpenRAN.pptx
@@ -6525,7 +6525,7 @@
                 </a:solidFill>
                 <a:latin typeface="Calibri"/>
               </a:rPr>
-              <a:t>3 elementos montados, com 46 e 97 módulos YANG anunciados.</a:t>
+              <a:t>3 elementos montados, com 33 e 84 módulos YANG anunciados.</a:t>
             </a:r>
           </a:p>
           <a:p>
@@ -11769,7 +11769,7 @@
                 </a:solidFill>
                 <a:latin typeface="Calibri"/>
               </a:rPr>
-              <a:t>Os três elementos simulados conectaram-se com 46, 97 e 97 módulos YANG anunciados.</a:t>
+              <a:t>Os três elementos conectaram-se anunciando 33, 84 e 84 módulos YANG, além de 13 capacidades de protocolo cada.</a:t>
             </a:r>
           </a:p>
         </p:txBody>

</xml_diff>

<commit_message>
Alinha documentação e capturas ao comportamento corrigido do portal
A Ajuda embutida e o relatório ainda descreviam a lista fixa de caminhos
sugeridos e diziam que um atalho inválido retornava 404. Passam a descrever a
sondagem no elemento e seus três estados, e a distinguir HTTP 400 (módulo não
anunciado) de 409 (ramo sem dado gravado).

Acrescenta ao diagnóstico dois casos observados em uso: código antigo servido
do cache do navegador, e a recusa do simulador em redefinir um tipo de política
que já tenha instâncias.

O relatório ganha a seção 12.1 sobre a suíte de testes, incluindo os dois
defeitos que ela revelou e por que passaram despercebidos numa inspeção visual
— a tela mostrava uma lista vazia, indistinguível de um estado legítimo sem
dados. Capturas e slides regenerados a partir da execução atual.
</commit_message>
<xml_diff>
--- a/docs/Apresentacao_Parte2_SMO_OpenRAN.pptx
+++ b/docs/Apresentacao_Parte2_SMO_OpenRAN.pptx
@@ -3888,8 +3888,8 @@
         </p:blipFill>
         <p:spPr>
           <a:xfrm>
-            <a:off x="7911752" y="1737360"/>
-            <a:ext cx="3607495" cy="2926080"/>
+            <a:off x="7818120" y="1737360"/>
+            <a:ext cx="3794760" cy="2853975"/>
           </a:xfrm>
           <a:prstGeom prst="rect">
             <a:avLst/>
@@ -6717,13 +6717,55 @@
       </p:sp>
       <p:sp>
         <p:nvSpPr>
-          <p:cNvPr id="8" name="Rounded Rectangle 7"/>
+          <p:cNvPr id="8" name="TextBox 7"/>
+          <p:cNvSpPr txBox="1"/>
+          <p:nvPr/>
+        </p:nvSpPr>
+        <p:spPr>
+          <a:xfrm>
+            <a:off x="548640" y="4846320"/>
+            <a:ext cx="11064240" cy="502920"/>
+          </a:xfrm>
+          <a:prstGeom prst="rect">
+            <a:avLst/>
+          </a:prstGeom>
+          <a:noFill/>
+        </p:spPr>
+        <p:txBody>
+          <a:bodyPr wrap="square" anchor="t" lIns="0" rIns="0" tIns="0" bIns="0">
+            <a:spAutoFit/>
+          </a:bodyPr>
+          <a:lstStyle/>
+          <a:p>
+            <a:pPr algn="l">
+              <a:lnSpc>
+                <a:spcPct val="100000"/>
+              </a:lnSpc>
+              <a:spcAft>
+                <a:spcPts val="400"/>
+              </a:spcAft>
+            </a:pPr>
+            <a:r>
+              <a:rPr sz="1300" b="0">
+                <a:solidFill>
+                  <a:srgbClr val="444F66"/>
+                </a:solidFill>
+                <a:latin typeface="Calibri"/>
+              </a:rPr>
+              <a:t>Além do roteiro, 87 testes automatizados sobre o portal — 60 de API e 27 de interface num navegador real, sem simulação de dependências.</a:t>
+            </a:r>
+          </a:p>
+        </p:txBody>
+      </p:sp>
+      <p:sp>
+        <p:nvSpPr>
+          <p:cNvPr id="9" name="Rounded Rectangle 8"/>
           <p:cNvSpPr/>
           <p:nvPr/>
         </p:nvSpPr>
         <p:spPr>
           <a:xfrm>
-            <a:off x="548640" y="4892040"/>
+            <a:off x="548640" y="5394960"/>
             <a:ext cx="11064240" cy="1005840"/>
           </a:xfrm>
           <a:prstGeom prst="roundRect">
@@ -6761,13 +6803,13 @@
       </p:sp>
       <p:sp>
         <p:nvSpPr>
-          <p:cNvPr id="9" name="TextBox 8"/>
+          <p:cNvPr id="10" name="TextBox 9"/>
           <p:cNvSpPr txBox="1"/>
           <p:nvPr/>
         </p:nvSpPr>
         <p:spPr>
           <a:xfrm>
-            <a:off x="914400" y="5074920"/>
+            <a:off x="914400" y="5577840"/>
             <a:ext cx="2743200" cy="640080"/>
           </a:xfrm>
           <a:prstGeom prst="rect">
@@ -6803,13 +6845,13 @@
       </p:sp>
       <p:sp>
         <p:nvSpPr>
-          <p:cNvPr id="10" name="TextBox 9"/>
+          <p:cNvPr id="11" name="TextBox 10"/>
           <p:cNvSpPr txBox="1"/>
           <p:nvPr/>
         </p:nvSpPr>
         <p:spPr>
           <a:xfrm>
-            <a:off x="3657600" y="5074920"/>
+            <a:off x="3657600" y="5577840"/>
             <a:ext cx="7680960" cy="640080"/>
           </a:xfrm>
           <a:prstGeom prst="rect">
@@ -6838,7 +6880,7 @@
                 </a:solidFill>
                 <a:latin typeface="Calibri"/>
               </a:rPr>
-              <a:t>Treze passos concluídos, nenhuma falha.</a:t>
+              <a:t>Treze passos concluídos, nenhuma falha. A suíte encontrou dois defeitos que o uso manual não revelara, ambos em nomes de campo de APIs de terceiros.</a:t>
             </a:r>
           </a:p>
         </p:txBody>

</xml_diff>

<commit_message>
Renomeia o repositório para smo-openran
O sufixo "parte2" descrevia a etapa da disciplina, não o conteúdo: o
repositório contém a implantação do SMO e o portal de operação, que não são
específicos de uma entrega. Atualiza as instruções de clone no README e as
referências no relatório e na apresentação.
</commit_message>
<xml_diff>
--- a/docs/Apresentacao_Parte2_SMO_OpenRAN.pptx
+++ b/docs/Apresentacao_Parte2_SMO_OpenRAN.pptx
@@ -3423,7 +3423,7 @@
                 </a:solidFill>
                 <a:latin typeface="Calibri"/>
               </a:rPr>
-              <a:t>github.com/felipefavilla/smo-openran-parte2</a:t>
+              <a:t>github.com/felipefavilla/smo-openran</a:t>
             </a:r>
           </a:p>
         </p:txBody>
@@ -8666,7 +8666,7 @@
                 </a:solidFill>
                 <a:latin typeface="Calibri"/>
               </a:rPr>
-              <a:t>Pilha completa, portal de operação, scripts de verificação e relatório publicados em github.com/felipefavilla/smo-openran-parte2</a:t>
+              <a:t>Pilha completa, portal de operação, scripts de verificação e relatório publicados em github.com/felipefavilla/smo-openran</a:t>
             </a:r>
           </a:p>
         </p:txBody>
@@ -9249,7 +9249,7 @@
                 </a:solidFill>
                 <a:latin typeface="Calibri"/>
               </a:rPr>
-              <a:t>github.com/felipefavilla/smo-openran-parte2</a:t>
+              <a:t>github.com/felipefavilla/smo-openran</a:t>
             </a:r>
           </a:p>
         </p:txBody>

</xml_diff>

<commit_message>
Ajusta relatório, apresentação e README conforme revisão
Relatório e apresentação:

- Removidas as referências ao repositório. A seção de instalação passa a
  assumir o diretório do projeto, começando em "cd deploy".
- Removida a indicação de quem apresenta no rodapé dos slides, redundante com
  os integrantes já listados na capa.
- Removida das referências a Parte 1 deste mesmo grupo, por ser autocitação.
- Corpo de texto do relatório justificado; títulos, legendas, blocos de código
  e células de tabela mantêm o alinhamento próprio.
- Todas as capturas do portal passam a usar o tema claro, inclusive as das
  telas de ciclo de vida e visão geral, antes em tema escuro.

Em toda a documentação e nos comentários de código, o radical "implanta" foi
trocado por "implementa" — 37 ocorrências, cobrindo implantação, implantada e
implantado.
</commit_message>
<xml_diff>
--- a/docs/Apresentacao_Parte2_SMO_OpenRAN.pptx
+++ b/docs/Apresentacao_Parte2_SMO_OpenRAN.pptx
@@ -3353,7 +3353,7 @@
         <p:spPr>
           <a:xfrm>
             <a:off x="1005840" y="6126480"/>
-            <a:ext cx="5486400" cy="365760"/>
+            <a:ext cx="10241280" cy="365760"/>
           </a:xfrm>
           <a:prstGeom prst="rect">
             <a:avLst/>
@@ -3382,48 +3382,6 @@
                 <a:latin typeface="Calibri"/>
               </a:rPr>
               <a:t>Setembro de 2026</a:t>
-            </a:r>
-          </a:p>
-        </p:txBody>
-      </p:sp>
-      <p:sp>
-        <p:nvSpPr>
-          <p:cNvPr id="8" name="TextBox 7"/>
-          <p:cNvSpPr txBox="1"/>
-          <p:nvPr/>
-        </p:nvSpPr>
-        <p:spPr>
-          <a:xfrm>
-            <a:off x="6583680" y="6126480"/>
-            <a:ext cx="4663440" cy="365760"/>
-          </a:xfrm>
-          <a:prstGeom prst="rect">
-            <a:avLst/>
-          </a:prstGeom>
-          <a:noFill/>
-        </p:spPr>
-        <p:txBody>
-          <a:bodyPr wrap="square" anchor="t" lIns="0" rIns="0" tIns="0" bIns="0">
-            <a:spAutoFit/>
-          </a:bodyPr>
-          <a:lstStyle/>
-          <a:p>
-            <a:pPr algn="r">
-              <a:lnSpc>
-                <a:spcPct val="100000"/>
-              </a:lnSpc>
-              <a:spcAft>
-                <a:spcPts val="400"/>
-              </a:spcAft>
-            </a:pPr>
-            <a:r>
-              <a:rPr sz="1200" b="0">
-                <a:solidFill>
-                  <a:srgbClr val="C8D3E6"/>
-                </a:solidFill>
-                <a:latin typeface="Calibri"/>
-              </a:rPr>
-              <a:t>github.com/felipefavilla/smo-openran</a:t>
             </a:r>
           </a:p>
         </p:txBody>
@@ -3547,7 +3505,7 @@
         <p:spPr>
           <a:xfrm>
             <a:off x="457200" y="6492240"/>
-            <a:ext cx="5943600" cy="274320"/>
+            <a:ext cx="8229600" cy="274320"/>
           </a:xfrm>
           <a:prstGeom prst="rect">
             <a:avLst/>
@@ -3588,8 +3546,8 @@
         </p:nvSpPr>
         <p:spPr>
           <a:xfrm>
-            <a:off x="7589520" y="6492240"/>
-            <a:ext cx="3566160" cy="274320"/>
+            <a:off x="11274552" y="6492240"/>
+            <a:ext cx="457200" cy="274320"/>
           </a:xfrm>
           <a:prstGeom prst="rect">
             <a:avLst/>
@@ -3617,7 +3575,7 @@
                 </a:solidFill>
                 <a:latin typeface="Calibri"/>
               </a:rPr>
-              <a:t>Apresenta: Felipe Bartholo Favilla</a:t>
+              <a:t>10</a:t>
             </a:r>
           </a:p>
         </p:txBody>
@@ -3625,48 +3583,6 @@
       <p:sp>
         <p:nvSpPr>
           <p:cNvPr id="6" name="TextBox 5"/>
-          <p:cNvSpPr txBox="1"/>
-          <p:nvPr/>
-        </p:nvSpPr>
-        <p:spPr>
-          <a:xfrm>
-            <a:off x="11274552" y="6492240"/>
-            <a:ext cx="457200" cy="274320"/>
-          </a:xfrm>
-          <a:prstGeom prst="rect">
-            <a:avLst/>
-          </a:prstGeom>
-          <a:noFill/>
-        </p:spPr>
-        <p:txBody>
-          <a:bodyPr wrap="square" anchor="t" lIns="0" rIns="0" tIns="0" bIns="0">
-            <a:spAutoFit/>
-          </a:bodyPr>
-          <a:lstStyle/>
-          <a:p>
-            <a:pPr algn="r">
-              <a:lnSpc>
-                <a:spcPct val="100000"/>
-              </a:lnSpc>
-              <a:spcAft>
-                <a:spcPts val="400"/>
-              </a:spcAft>
-            </a:pPr>
-            <a:r>
-              <a:rPr sz="900" b="0">
-                <a:solidFill>
-                  <a:srgbClr val="5C6B84"/>
-                </a:solidFill>
-                <a:latin typeface="Calibri"/>
-              </a:rPr>
-              <a:t>10</a:t>
-            </a:r>
-          </a:p>
-        </p:txBody>
-      </p:sp>
-      <p:sp>
-        <p:nvSpPr>
-          <p:cNvPr id="7" name="TextBox 6"/>
           <p:cNvSpPr txBox="1"/>
           <p:nvPr/>
         </p:nvSpPr>
@@ -3874,7 +3790,7 @@
       </p:sp>
       <p:pic>
         <p:nvPicPr>
-          <p:cNvPr id="8" name="Picture 7" descr="politicas-a1-light.png"/>
+          <p:cNvPr id="7" name="Picture 6" descr="politicas-a1-light.png"/>
           <p:cNvPicPr>
             <a:picLocks noChangeAspect="1"/>
           </p:cNvPicPr>
@@ -3903,7 +3819,7 @@
       </p:pic>
       <p:sp>
         <p:nvSpPr>
-          <p:cNvPr id="9" name="Rounded Rectangle 8"/>
+          <p:cNvPr id="8" name="Rounded Rectangle 7"/>
           <p:cNvSpPr/>
           <p:nvPr/>
         </p:nvSpPr>
@@ -3947,7 +3863,7 @@
       </p:sp>
       <p:sp>
         <p:nvSpPr>
-          <p:cNvPr id="10" name="TextBox 9"/>
+          <p:cNvPr id="9" name="TextBox 8"/>
           <p:cNvSpPr txBox="1"/>
           <p:nvPr/>
         </p:nvSpPr>
@@ -3989,7 +3905,7 @@
       </p:sp>
       <p:sp>
         <p:nvSpPr>
-          <p:cNvPr id="11" name="TextBox 10"/>
+          <p:cNvPr id="10" name="TextBox 9"/>
           <p:cNvSpPr txBox="1"/>
           <p:nvPr/>
         </p:nvSpPr>
@@ -4148,7 +4064,7 @@
         <p:spPr>
           <a:xfrm>
             <a:off x="457200" y="6492240"/>
-            <a:ext cx="5943600" cy="274320"/>
+            <a:ext cx="8229600" cy="274320"/>
           </a:xfrm>
           <a:prstGeom prst="rect">
             <a:avLst/>
@@ -4189,8 +4105,8 @@
         </p:nvSpPr>
         <p:spPr>
           <a:xfrm>
-            <a:off x="7589520" y="6492240"/>
-            <a:ext cx="3566160" cy="274320"/>
+            <a:off x="11274552" y="6492240"/>
+            <a:ext cx="457200" cy="274320"/>
           </a:xfrm>
           <a:prstGeom prst="rect">
             <a:avLst/>
@@ -4218,48 +4134,6 @@
                 </a:solidFill>
                 <a:latin typeface="Calibri"/>
               </a:rPr>
-              <a:t>Apresenta: Felipe Bartholo Favilla</a:t>
-            </a:r>
-          </a:p>
-        </p:txBody>
-      </p:sp>
-      <p:sp>
-        <p:nvSpPr>
-          <p:cNvPr id="6" name="TextBox 5"/>
-          <p:cNvSpPr txBox="1"/>
-          <p:nvPr/>
-        </p:nvSpPr>
-        <p:spPr>
-          <a:xfrm>
-            <a:off x="11274552" y="6492240"/>
-            <a:ext cx="457200" cy="274320"/>
-          </a:xfrm>
-          <a:prstGeom prst="rect">
-            <a:avLst/>
-          </a:prstGeom>
-          <a:noFill/>
-        </p:spPr>
-        <p:txBody>
-          <a:bodyPr wrap="square" anchor="t" lIns="0" rIns="0" tIns="0" bIns="0">
-            <a:spAutoFit/>
-          </a:bodyPr>
-          <a:lstStyle/>
-          <a:p>
-            <a:pPr algn="r">
-              <a:lnSpc>
-                <a:spcPct val="100000"/>
-              </a:lnSpc>
-              <a:spcAft>
-                <a:spcPts val="400"/>
-              </a:spcAft>
-            </a:pPr>
-            <a:r>
-              <a:rPr sz="900" b="0">
-                <a:solidFill>
-                  <a:srgbClr val="5C6B84"/>
-                </a:solidFill>
-                <a:latin typeface="Calibri"/>
-              </a:rPr>
               <a:t>11</a:t>
             </a:r>
           </a:p>
@@ -4267,7 +4141,7 @@
       </p:sp>
       <p:sp>
         <p:nvSpPr>
-          <p:cNvPr id="7" name="Rounded Rectangle 6"/>
+          <p:cNvPr id="6" name="Rounded Rectangle 5"/>
           <p:cNvSpPr/>
           <p:nvPr/>
         </p:nvSpPr>
@@ -4313,7 +4187,7 @@
       </p:sp>
       <p:sp>
         <p:nvSpPr>
-          <p:cNvPr id="8" name="Rounded Rectangle 7"/>
+          <p:cNvPr id="7" name="Rounded Rectangle 6"/>
           <p:cNvSpPr/>
           <p:nvPr/>
         </p:nvSpPr>
@@ -4368,7 +4242,7 @@
       </p:sp>
       <p:sp>
         <p:nvSpPr>
-          <p:cNvPr id="9" name="TextBox 8"/>
+          <p:cNvPr id="8" name="TextBox 7"/>
           <p:cNvSpPr txBox="1"/>
           <p:nvPr/>
         </p:nvSpPr>
@@ -4410,7 +4284,7 @@
       </p:sp>
       <p:sp>
         <p:nvSpPr>
-          <p:cNvPr id="10" name="TextBox 9"/>
+          <p:cNvPr id="9" name="TextBox 8"/>
           <p:cNvSpPr txBox="1"/>
           <p:nvPr/>
         </p:nvSpPr>
@@ -4452,7 +4326,7 @@
       </p:sp>
       <p:sp>
         <p:nvSpPr>
-          <p:cNvPr id="11" name="Rounded Rectangle 10"/>
+          <p:cNvPr id="10" name="Rounded Rectangle 9"/>
           <p:cNvSpPr/>
           <p:nvPr/>
         </p:nvSpPr>
@@ -4498,7 +4372,7 @@
       </p:sp>
       <p:sp>
         <p:nvSpPr>
-          <p:cNvPr id="12" name="Rounded Rectangle 11"/>
+          <p:cNvPr id="11" name="Rounded Rectangle 10"/>
           <p:cNvSpPr/>
           <p:nvPr/>
         </p:nvSpPr>
@@ -4553,7 +4427,7 @@
       </p:sp>
       <p:sp>
         <p:nvSpPr>
-          <p:cNvPr id="13" name="TextBox 12"/>
+          <p:cNvPr id="12" name="TextBox 11"/>
           <p:cNvSpPr txBox="1"/>
           <p:nvPr/>
         </p:nvSpPr>
@@ -4595,7 +4469,7 @@
       </p:sp>
       <p:sp>
         <p:nvSpPr>
-          <p:cNvPr id="14" name="TextBox 13"/>
+          <p:cNvPr id="13" name="TextBox 12"/>
           <p:cNvSpPr txBox="1"/>
           <p:nvPr/>
         </p:nvSpPr>
@@ -4637,7 +4511,7 @@
       </p:sp>
       <p:sp>
         <p:nvSpPr>
-          <p:cNvPr id="15" name="Rounded Rectangle 14"/>
+          <p:cNvPr id="14" name="Rounded Rectangle 13"/>
           <p:cNvSpPr/>
           <p:nvPr/>
         </p:nvSpPr>
@@ -4683,7 +4557,7 @@
       </p:sp>
       <p:sp>
         <p:nvSpPr>
-          <p:cNvPr id="16" name="Rounded Rectangle 15"/>
+          <p:cNvPr id="15" name="Rounded Rectangle 14"/>
           <p:cNvSpPr/>
           <p:nvPr/>
         </p:nvSpPr>
@@ -4738,7 +4612,7 @@
       </p:sp>
       <p:sp>
         <p:nvSpPr>
-          <p:cNvPr id="17" name="TextBox 16"/>
+          <p:cNvPr id="16" name="TextBox 15"/>
           <p:cNvSpPr txBox="1"/>
           <p:nvPr/>
         </p:nvSpPr>
@@ -4780,7 +4654,7 @@
       </p:sp>
       <p:sp>
         <p:nvSpPr>
-          <p:cNvPr id="18" name="TextBox 17"/>
+          <p:cNvPr id="17" name="TextBox 16"/>
           <p:cNvSpPr txBox="1"/>
           <p:nvPr/>
         </p:nvSpPr>
@@ -4822,7 +4696,7 @@
       </p:sp>
       <p:sp>
         <p:nvSpPr>
-          <p:cNvPr id="19" name="Rounded Rectangle 18"/>
+          <p:cNvPr id="18" name="Rounded Rectangle 17"/>
           <p:cNvSpPr/>
           <p:nvPr/>
         </p:nvSpPr>
@@ -4866,7 +4740,7 @@
       </p:sp>
       <p:sp>
         <p:nvSpPr>
-          <p:cNvPr id="20" name="TextBox 19"/>
+          <p:cNvPr id="19" name="TextBox 18"/>
           <p:cNvSpPr txBox="1"/>
           <p:nvPr/>
         </p:nvSpPr>
@@ -4908,7 +4782,7 @@
       </p:sp>
       <p:sp>
         <p:nvSpPr>
-          <p:cNvPr id="21" name="TextBox 20"/>
+          <p:cNvPr id="20" name="TextBox 19"/>
           <p:cNvSpPr txBox="1"/>
           <p:nvPr/>
         </p:nvSpPr>
@@ -4943,7 +4817,7 @@
                 </a:solidFill>
                 <a:latin typeface="Calibri"/>
               </a:rPr>
-              <a:t>Em Kubernetes o ciclo de vida passaria a Helm; sobre O-Cloud, à função O2dms. Ambos fora do escopo desta implantação, como a Parte 1 já antecipava.</a:t>
+              <a:t>Em Kubernetes o ciclo de vida passaria a Helm; sobre O-Cloud, à função O2dms. Ambos fora do escopo desta implementação, como a Parte 1 já antecipava.</a:t>
             </a:r>
           </a:p>
         </p:txBody>
@@ -5067,7 +4941,7 @@
         <p:spPr>
           <a:xfrm>
             <a:off x="457200" y="6492240"/>
-            <a:ext cx="5943600" cy="274320"/>
+            <a:ext cx="8229600" cy="274320"/>
           </a:xfrm>
           <a:prstGeom prst="rect">
             <a:avLst/>
@@ -5108,8 +4982,8 @@
         </p:nvSpPr>
         <p:spPr>
           <a:xfrm>
-            <a:off x="7589520" y="6492240"/>
-            <a:ext cx="3566160" cy="274320"/>
+            <a:off x="11274552" y="6492240"/>
+            <a:ext cx="457200" cy="274320"/>
           </a:xfrm>
           <a:prstGeom prst="rect">
             <a:avLst/>
@@ -5137,48 +5011,6 @@
                 </a:solidFill>
                 <a:latin typeface="Calibri"/>
               </a:rPr>
-              <a:t>Apresenta: Felipe Bartholo Favilla</a:t>
-            </a:r>
-          </a:p>
-        </p:txBody>
-      </p:sp>
-      <p:sp>
-        <p:nvSpPr>
-          <p:cNvPr id="6" name="TextBox 5"/>
-          <p:cNvSpPr txBox="1"/>
-          <p:nvPr/>
-        </p:nvSpPr>
-        <p:spPr>
-          <a:xfrm>
-            <a:off x="11274552" y="6492240"/>
-            <a:ext cx="457200" cy="274320"/>
-          </a:xfrm>
-          <a:prstGeom prst="rect">
-            <a:avLst/>
-          </a:prstGeom>
-          <a:noFill/>
-        </p:spPr>
-        <p:txBody>
-          <a:bodyPr wrap="square" anchor="t" lIns="0" rIns="0" tIns="0" bIns="0">
-            <a:spAutoFit/>
-          </a:bodyPr>
-          <a:lstStyle/>
-          <a:p>
-            <a:pPr algn="r">
-              <a:lnSpc>
-                <a:spcPct val="100000"/>
-              </a:lnSpc>
-              <a:spcAft>
-                <a:spcPts val="400"/>
-              </a:spcAft>
-            </a:pPr>
-            <a:r>
-              <a:rPr sz="900" b="0">
-                <a:solidFill>
-                  <a:srgbClr val="5C6B84"/>
-                </a:solidFill>
-                <a:latin typeface="Calibri"/>
-              </a:rPr>
               <a:t>12</a:t>
             </a:r>
           </a:p>
@@ -5186,7 +5018,7 @@
       </p:sp>
       <p:pic>
         <p:nvPicPr>
-          <p:cNvPr id="7" name="Picture 6" descr="visao-geral-light.png"/>
+          <p:cNvPr id="6" name="Picture 5" descr="visao-geral-light.png"/>
           <p:cNvPicPr>
             <a:picLocks noChangeAspect="1"/>
           </p:cNvPicPr>
@@ -5215,7 +5047,7 @@
       </p:pic>
       <p:sp>
         <p:nvSpPr>
-          <p:cNvPr id="8" name="TextBox 7"/>
+          <p:cNvPr id="7" name="TextBox 6"/>
           <p:cNvSpPr txBox="1"/>
           <p:nvPr/>
         </p:nvSpPr>
@@ -5350,7 +5182,7 @@
       </p:sp>
       <p:sp>
         <p:nvSpPr>
-          <p:cNvPr id="9" name="TextBox 8"/>
+          <p:cNvPr id="8" name="TextBox 7"/>
           <p:cNvSpPr txBox="1"/>
           <p:nvPr/>
         </p:nvSpPr>
@@ -5585,7 +5417,7 @@
         <p:spPr>
           <a:xfrm>
             <a:off x="457200" y="6492240"/>
-            <a:ext cx="5943600" cy="274320"/>
+            <a:ext cx="8229600" cy="274320"/>
           </a:xfrm>
           <a:prstGeom prst="rect">
             <a:avLst/>
@@ -5626,8 +5458,8 @@
         </p:nvSpPr>
         <p:spPr>
           <a:xfrm>
-            <a:off x="7589520" y="6492240"/>
-            <a:ext cx="3566160" cy="274320"/>
+            <a:off x="11274552" y="6492240"/>
+            <a:ext cx="457200" cy="274320"/>
           </a:xfrm>
           <a:prstGeom prst="rect">
             <a:avLst/>
@@ -5655,48 +5487,6 @@
                 </a:solidFill>
                 <a:latin typeface="Calibri"/>
               </a:rPr>
-              <a:t>Apresenta: Felipe Bartholo Favilla</a:t>
-            </a:r>
-          </a:p>
-        </p:txBody>
-      </p:sp>
-      <p:sp>
-        <p:nvSpPr>
-          <p:cNvPr id="6" name="TextBox 5"/>
-          <p:cNvSpPr txBox="1"/>
-          <p:nvPr/>
-        </p:nvSpPr>
-        <p:spPr>
-          <a:xfrm>
-            <a:off x="11274552" y="6492240"/>
-            <a:ext cx="457200" cy="274320"/>
-          </a:xfrm>
-          <a:prstGeom prst="rect">
-            <a:avLst/>
-          </a:prstGeom>
-          <a:noFill/>
-        </p:spPr>
-        <p:txBody>
-          <a:bodyPr wrap="square" anchor="t" lIns="0" rIns="0" tIns="0" bIns="0">
-            <a:spAutoFit/>
-          </a:bodyPr>
-          <a:lstStyle/>
-          <a:p>
-            <a:pPr algn="r">
-              <a:lnSpc>
-                <a:spcPct val="100000"/>
-              </a:lnSpc>
-              <a:spcAft>
-                <a:spcPts val="400"/>
-              </a:spcAft>
-            </a:pPr>
-            <a:r>
-              <a:rPr sz="900" b="0">
-                <a:solidFill>
-                  <a:srgbClr val="5C6B84"/>
-                </a:solidFill>
-                <a:latin typeface="Calibri"/>
-              </a:rPr>
               <a:t>13</a:t>
             </a:r>
           </a:p>
@@ -5704,7 +5494,7 @@
       </p:sp>
       <p:graphicFrame>
         <p:nvGraphicFramePr>
-          <p:cNvPr id="7" name="Table 6"/>
+          <p:cNvPr id="6" name="Table 5"/>
           <p:cNvGraphicFramePr>
             <a:graphicFrameLocks noGrp="1"/>
           </p:cNvGraphicFramePr>
@@ -6071,7 +5861,7 @@
       </p:graphicFrame>
       <p:sp>
         <p:nvSpPr>
-          <p:cNvPr id="8" name="Rounded Rectangle 7"/>
+          <p:cNvPr id="7" name="Rounded Rectangle 6"/>
           <p:cNvSpPr/>
           <p:nvPr/>
         </p:nvSpPr>
@@ -6115,7 +5905,7 @@
       </p:sp>
       <p:sp>
         <p:nvSpPr>
-          <p:cNvPr id="9" name="TextBox 8"/>
+          <p:cNvPr id="8" name="TextBox 7"/>
           <p:cNvSpPr txBox="1"/>
           <p:nvPr/>
         </p:nvSpPr>
@@ -6157,7 +5947,7 @@
       </p:sp>
       <p:sp>
         <p:nvSpPr>
-          <p:cNvPr id="10" name="TextBox 9"/>
+          <p:cNvPr id="9" name="TextBox 8"/>
           <p:cNvSpPr txBox="1"/>
           <p:nvPr/>
         </p:nvSpPr>
@@ -6192,7 +5982,7 @@
                 </a:solidFill>
                 <a:latin typeface="Calibri"/>
               </a:rPr>
-              <a:t>Nenhum era defeito funcional de um módulo. Todos eram problemas de montagem — e é neles que o tempo de uma implantação real se concentra.</a:t>
+              <a:t>Nenhum era defeito funcional de um módulo. Todos eram problemas de montagem — e é neles que o tempo de uma implementação real se concentra.</a:t>
             </a:r>
           </a:p>
         </p:txBody>
@@ -6316,7 +6106,7 @@
         <p:spPr>
           <a:xfrm>
             <a:off x="457200" y="6492240"/>
-            <a:ext cx="5943600" cy="274320"/>
+            <a:ext cx="8229600" cy="274320"/>
           </a:xfrm>
           <a:prstGeom prst="rect">
             <a:avLst/>
@@ -6357,8 +6147,8 @@
         </p:nvSpPr>
         <p:spPr>
           <a:xfrm>
-            <a:off x="7589520" y="6492240"/>
-            <a:ext cx="3566160" cy="274320"/>
+            <a:off x="11274552" y="6492240"/>
+            <a:ext cx="457200" cy="274320"/>
           </a:xfrm>
           <a:prstGeom prst="rect">
             <a:avLst/>
@@ -6386,7 +6176,7 @@
                 </a:solidFill>
                 <a:latin typeface="Calibri"/>
               </a:rPr>
-              <a:t>Apresenta: Felipe Bartholo Favilla</a:t>
+              <a:t>14</a:t>
             </a:r>
           </a:p>
         </p:txBody>
@@ -6399,8 +6189,290 @@
         </p:nvSpPr>
         <p:spPr>
           <a:xfrm>
-            <a:off x="11274552" y="6492240"/>
-            <a:ext cx="457200" cy="274320"/>
+            <a:off x="548640" y="1737360"/>
+            <a:ext cx="11064240" cy="3108960"/>
+          </a:xfrm>
+          <a:prstGeom prst="rect">
+            <a:avLst/>
+          </a:prstGeom>
+          <a:noFill/>
+        </p:spPr>
+        <p:txBody>
+          <a:bodyPr wrap="square" lIns="0" rIns="0" tIns="0" bIns="0">
+            <a:spAutoFit/>
+          </a:bodyPr>
+          <a:lstStyle/>
+          <a:p>
+            <a:pPr>
+              <a:lnSpc>
+                <a:spcPct val="120000"/>
+              </a:lnSpc>
+              <a:spcAft>
+                <a:spcPts val="1000"/>
+              </a:spcAft>
+            </a:pPr>
+            <a:r>
+              <a:rPr sz="1400" b="1">
+                <a:solidFill>
+                  <a:srgbClr val="3F5B8C"/>
+                </a:solidFill>
+                <a:latin typeface="Calibri"/>
+              </a:rPr>
+              <a:t>•   </a:t>
+            </a:r>
+            <a:r>
+              <a:rPr sz="1400" b="1">
+                <a:solidFill>
+                  <a:srgbClr val="1F2A44"/>
+                </a:solidFill>
+                <a:latin typeface="Calibri"/>
+              </a:rPr>
+              <a:t>Saúde da pilha. </a:t>
+            </a:r>
+            <a:r>
+              <a:rPr sz="1400">
+                <a:solidFill>
+                  <a:srgbClr val="444F66"/>
+                </a:solidFill>
+                <a:latin typeface="Calibri"/>
+              </a:rPr>
+              <a:t>Nenhum serviço em estado unhealthy.</a:t>
+            </a:r>
+          </a:p>
+          <a:p>
+            <a:pPr>
+              <a:lnSpc>
+                <a:spcPct val="120000"/>
+              </a:lnSpc>
+              <a:spcAft>
+                <a:spcPts val="1000"/>
+              </a:spcAft>
+            </a:pPr>
+            <a:r>
+              <a:rPr sz="1400" b="1">
+                <a:solidFill>
+                  <a:srgbClr val="3F5B8C"/>
+                </a:solidFill>
+                <a:latin typeface="Calibri"/>
+              </a:rPr>
+              <a:t>•   </a:t>
+            </a:r>
+            <a:r>
+              <a:rPr sz="1400" b="1">
+                <a:solidFill>
+                  <a:srgbClr val="1F2A44"/>
+                </a:solidFill>
+                <a:latin typeface="Calibri"/>
+              </a:rPr>
+              <a:t>O1 — descoberta. </a:t>
+            </a:r>
+            <a:r>
+              <a:rPr sz="1400">
+                <a:solidFill>
+                  <a:srgbClr val="444F66"/>
+                </a:solidFill>
+                <a:latin typeface="Calibri"/>
+              </a:rPr>
+              <a:t>3 elementos montados, com 33 e 84 módulos YANG anunciados.</a:t>
+            </a:r>
+          </a:p>
+          <a:p>
+            <a:pPr>
+              <a:lnSpc>
+                <a:spcPct val="120000"/>
+              </a:lnSpc>
+              <a:spcAft>
+                <a:spcPts val="1000"/>
+              </a:spcAft>
+            </a:pPr>
+            <a:r>
+              <a:rPr sz="1400" b="1">
+                <a:solidFill>
+                  <a:srgbClr val="3F5B8C"/>
+                </a:solidFill>
+                <a:latin typeface="Calibri"/>
+              </a:rPr>
+              <a:t>•   </a:t>
+            </a:r>
+            <a:r>
+              <a:rPr sz="1400" b="1">
+                <a:solidFill>
+                  <a:srgbClr val="1F2A44"/>
+                </a:solidFill>
+                <a:latin typeface="Calibri"/>
+              </a:rPr>
+              <a:t>O1 — configuração. </a:t>
+            </a:r>
+            <a:r>
+              <a:rPr sz="1400">
+                <a:solidFill>
+                  <a:srgbClr val="444F66"/>
+                </a:solidFill>
+                <a:latin typeface="Calibri"/>
+              </a:rPr>
+              <a:t>Leitura HTTP 200; escrita HTTP 204 confirmada por releitura do datastore.</a:t>
+            </a:r>
+          </a:p>
+          <a:p>
+            <a:pPr>
+              <a:lnSpc>
+                <a:spcPct val="120000"/>
+              </a:lnSpc>
+              <a:spcAft>
+                <a:spcPts val="1000"/>
+              </a:spcAft>
+            </a:pPr>
+            <a:r>
+              <a:rPr sz="1400" b="1">
+                <a:solidFill>
+                  <a:srgbClr val="3F5B8C"/>
+                </a:solidFill>
+                <a:latin typeface="Calibri"/>
+              </a:rPr>
+              <a:t>•   </a:t>
+            </a:r>
+            <a:r>
+              <a:rPr sz="1400" b="1">
+                <a:solidFill>
+                  <a:srgbClr val="1F2A44"/>
+                </a:solidFill>
+                <a:latin typeface="Calibri"/>
+              </a:rPr>
+              <a:t>O1 — telemetria. </a:t>
+            </a:r>
+            <a:r>
+              <a:rPr sz="1400">
+                <a:solidFill>
+                  <a:srgbClr val="444F66"/>
+                </a:solidFill>
+                <a:latin typeface="Calibri"/>
+              </a:rPr>
+              <a:t>8 tópicos VES criados pelo coletor e consumidos pelo portal.</a:t>
+            </a:r>
+          </a:p>
+          <a:p>
+            <a:pPr>
+              <a:lnSpc>
+                <a:spcPct val="120000"/>
+              </a:lnSpc>
+              <a:spcAft>
+                <a:spcPts val="1000"/>
+              </a:spcAft>
+            </a:pPr>
+            <a:r>
+              <a:rPr sz="1400" b="1">
+                <a:solidFill>
+                  <a:srgbClr val="3F5B8C"/>
+                </a:solidFill>
+                <a:latin typeface="Calibri"/>
+              </a:rPr>
+              <a:t>•   </a:t>
+            </a:r>
+            <a:r>
+              <a:rPr sz="1400" b="1">
+                <a:solidFill>
+                  <a:srgbClr val="1F2A44"/>
+                </a:solidFill>
+                <a:latin typeface="Calibri"/>
+              </a:rPr>
+              <a:t>Falhas. </a:t>
+            </a:r>
+            <a:r>
+              <a:rPr sz="1400">
+                <a:solidFill>
+                  <a:srgbClr val="444F66"/>
+                </a:solidFill>
+                <a:latin typeface="Calibri"/>
+              </a:rPr>
+              <a:t>Evento injetado aceito com HTTP 202 e visível como alarme crítico no portal.</a:t>
+            </a:r>
+          </a:p>
+          <a:p>
+            <a:pPr>
+              <a:lnSpc>
+                <a:spcPct val="120000"/>
+              </a:lnSpc>
+              <a:spcAft>
+                <a:spcPts val="1000"/>
+              </a:spcAft>
+            </a:pPr>
+            <a:r>
+              <a:rPr sz="1400" b="1">
+                <a:solidFill>
+                  <a:srgbClr val="3F5B8C"/>
+                </a:solidFill>
+                <a:latin typeface="Calibri"/>
+              </a:rPr>
+              <a:t>•   </a:t>
+            </a:r>
+            <a:r>
+              <a:rPr sz="1400" b="1">
+                <a:solidFill>
+                  <a:srgbClr val="1F2A44"/>
+                </a:solidFill>
+                <a:latin typeface="Calibri"/>
+              </a:rPr>
+              <a:t>A1. </a:t>
+            </a:r>
+            <a:r>
+              <a:rPr sz="1400">
+                <a:solidFill>
+                  <a:srgbClr val="444F66"/>
+                </a:solidFill>
+                <a:latin typeface="Calibri"/>
+              </a:rPr>
+              <a:t>Política criada (201), confirmada no Near-RT RIC e removida (204).</a:t>
+            </a:r>
+          </a:p>
+          <a:p>
+            <a:pPr>
+              <a:lnSpc>
+                <a:spcPct val="120000"/>
+              </a:lnSpc>
+              <a:spcAft>
+                <a:spcPts val="1000"/>
+              </a:spcAft>
+            </a:pPr>
+            <a:r>
+              <a:rPr sz="1400" b="1">
+                <a:solidFill>
+                  <a:srgbClr val="3F5B8C"/>
+                </a:solidFill>
+                <a:latin typeface="Calibri"/>
+              </a:rPr>
+              <a:t>•   </a:t>
+            </a:r>
+            <a:r>
+              <a:rPr sz="1400" b="1">
+                <a:solidFill>
+                  <a:srgbClr val="1F2A44"/>
+                </a:solidFill>
+                <a:latin typeface="Calibri"/>
+              </a:rPr>
+              <a:t>Ciclo de vida. </a:t>
+            </a:r>
+            <a:r>
+              <a:rPr sz="1400">
+                <a:solidFill>
+                  <a:srgbClr val="444F66"/>
+                </a:solidFill>
+                <a:latin typeface="Calibri"/>
+              </a:rPr>
+              <a:t>Parada derruba o mountpoint O1; reinício restabelece por registro automático.</a:t>
+            </a:r>
+          </a:p>
+        </p:txBody>
+      </p:sp>
+      <p:sp>
+        <p:nvSpPr>
+          <p:cNvPr id="7" name="TextBox 6"/>
+          <p:cNvSpPr txBox="1"/>
+          <p:nvPr/>
+        </p:nvSpPr>
+        <p:spPr>
+          <a:xfrm>
+            <a:off x="548640" y="4846320"/>
+            <a:ext cx="11064240" cy="502920"/>
           </a:xfrm>
           <a:prstGeom prst="rect">
             <a:avLst/>
@@ -6413,7 +6485,7 @@
           </a:bodyPr>
           <a:lstStyle/>
           <a:p>
-            <a:pPr algn="r">
+            <a:pPr algn="l">
               <a:lnSpc>
                 <a:spcPct val="100000"/>
               </a:lnSpc>
@@ -6422,336 +6494,12 @@
               </a:spcAft>
             </a:pPr>
             <a:r>
-              <a:rPr sz="900" b="0">
-                <a:solidFill>
-                  <a:srgbClr val="5C6B84"/>
-                </a:solidFill>
-                <a:latin typeface="Calibri"/>
-              </a:rPr>
-              <a:t>14</a:t>
-            </a:r>
-          </a:p>
-        </p:txBody>
-      </p:sp>
-      <p:sp>
-        <p:nvSpPr>
-          <p:cNvPr id="7" name="TextBox 6"/>
-          <p:cNvSpPr txBox="1"/>
-          <p:nvPr/>
-        </p:nvSpPr>
-        <p:spPr>
-          <a:xfrm>
-            <a:off x="548640" y="1737360"/>
-            <a:ext cx="11064240" cy="3108960"/>
-          </a:xfrm>
-          <a:prstGeom prst="rect">
-            <a:avLst/>
-          </a:prstGeom>
-          <a:noFill/>
-        </p:spPr>
-        <p:txBody>
-          <a:bodyPr wrap="square" lIns="0" rIns="0" tIns="0" bIns="0">
-            <a:spAutoFit/>
-          </a:bodyPr>
-          <a:lstStyle/>
-          <a:p>
-            <a:pPr>
-              <a:lnSpc>
-                <a:spcPct val="120000"/>
-              </a:lnSpc>
-              <a:spcAft>
-                <a:spcPts val="1000"/>
-              </a:spcAft>
-            </a:pPr>
-            <a:r>
-              <a:rPr sz="1400" b="1">
-                <a:solidFill>
-                  <a:srgbClr val="3F5B8C"/>
-                </a:solidFill>
-                <a:latin typeface="Calibri"/>
-              </a:rPr>
-              <a:t>•   </a:t>
-            </a:r>
-            <a:r>
-              <a:rPr sz="1400" b="1">
-                <a:solidFill>
-                  <a:srgbClr val="1F2A44"/>
-                </a:solidFill>
-                <a:latin typeface="Calibri"/>
-              </a:rPr>
-              <a:t>Saúde da pilha. </a:t>
-            </a:r>
-            <a:r>
-              <a:rPr sz="1400">
+              <a:rPr sz="1300" b="0">
                 <a:solidFill>
                   <a:srgbClr val="444F66"/>
                 </a:solidFill>
                 <a:latin typeface="Calibri"/>
               </a:rPr>
-              <a:t>Nenhum serviço em estado unhealthy.</a:t>
-            </a:r>
-          </a:p>
-          <a:p>
-            <a:pPr>
-              <a:lnSpc>
-                <a:spcPct val="120000"/>
-              </a:lnSpc>
-              <a:spcAft>
-                <a:spcPts val="1000"/>
-              </a:spcAft>
-            </a:pPr>
-            <a:r>
-              <a:rPr sz="1400" b="1">
-                <a:solidFill>
-                  <a:srgbClr val="3F5B8C"/>
-                </a:solidFill>
-                <a:latin typeface="Calibri"/>
-              </a:rPr>
-              <a:t>•   </a:t>
-            </a:r>
-            <a:r>
-              <a:rPr sz="1400" b="1">
-                <a:solidFill>
-                  <a:srgbClr val="1F2A44"/>
-                </a:solidFill>
-                <a:latin typeface="Calibri"/>
-              </a:rPr>
-              <a:t>O1 — descoberta. </a:t>
-            </a:r>
-            <a:r>
-              <a:rPr sz="1400">
-                <a:solidFill>
-                  <a:srgbClr val="444F66"/>
-                </a:solidFill>
-                <a:latin typeface="Calibri"/>
-              </a:rPr>
-              <a:t>3 elementos montados, com 33 e 84 módulos YANG anunciados.</a:t>
-            </a:r>
-          </a:p>
-          <a:p>
-            <a:pPr>
-              <a:lnSpc>
-                <a:spcPct val="120000"/>
-              </a:lnSpc>
-              <a:spcAft>
-                <a:spcPts val="1000"/>
-              </a:spcAft>
-            </a:pPr>
-            <a:r>
-              <a:rPr sz="1400" b="1">
-                <a:solidFill>
-                  <a:srgbClr val="3F5B8C"/>
-                </a:solidFill>
-                <a:latin typeface="Calibri"/>
-              </a:rPr>
-              <a:t>•   </a:t>
-            </a:r>
-            <a:r>
-              <a:rPr sz="1400" b="1">
-                <a:solidFill>
-                  <a:srgbClr val="1F2A44"/>
-                </a:solidFill>
-                <a:latin typeface="Calibri"/>
-              </a:rPr>
-              <a:t>O1 — configuração. </a:t>
-            </a:r>
-            <a:r>
-              <a:rPr sz="1400">
-                <a:solidFill>
-                  <a:srgbClr val="444F66"/>
-                </a:solidFill>
-                <a:latin typeface="Calibri"/>
-              </a:rPr>
-              <a:t>Leitura HTTP 200; escrita HTTP 204 confirmada por releitura do datastore.</a:t>
-            </a:r>
-          </a:p>
-          <a:p>
-            <a:pPr>
-              <a:lnSpc>
-                <a:spcPct val="120000"/>
-              </a:lnSpc>
-              <a:spcAft>
-                <a:spcPts val="1000"/>
-              </a:spcAft>
-            </a:pPr>
-            <a:r>
-              <a:rPr sz="1400" b="1">
-                <a:solidFill>
-                  <a:srgbClr val="3F5B8C"/>
-                </a:solidFill>
-                <a:latin typeface="Calibri"/>
-              </a:rPr>
-              <a:t>•   </a:t>
-            </a:r>
-            <a:r>
-              <a:rPr sz="1400" b="1">
-                <a:solidFill>
-                  <a:srgbClr val="1F2A44"/>
-                </a:solidFill>
-                <a:latin typeface="Calibri"/>
-              </a:rPr>
-              <a:t>O1 — telemetria. </a:t>
-            </a:r>
-            <a:r>
-              <a:rPr sz="1400">
-                <a:solidFill>
-                  <a:srgbClr val="444F66"/>
-                </a:solidFill>
-                <a:latin typeface="Calibri"/>
-              </a:rPr>
-              <a:t>8 tópicos VES criados pelo coletor e consumidos pelo portal.</a:t>
-            </a:r>
-          </a:p>
-          <a:p>
-            <a:pPr>
-              <a:lnSpc>
-                <a:spcPct val="120000"/>
-              </a:lnSpc>
-              <a:spcAft>
-                <a:spcPts val="1000"/>
-              </a:spcAft>
-            </a:pPr>
-            <a:r>
-              <a:rPr sz="1400" b="1">
-                <a:solidFill>
-                  <a:srgbClr val="3F5B8C"/>
-                </a:solidFill>
-                <a:latin typeface="Calibri"/>
-              </a:rPr>
-              <a:t>•   </a:t>
-            </a:r>
-            <a:r>
-              <a:rPr sz="1400" b="1">
-                <a:solidFill>
-                  <a:srgbClr val="1F2A44"/>
-                </a:solidFill>
-                <a:latin typeface="Calibri"/>
-              </a:rPr>
-              <a:t>Falhas. </a:t>
-            </a:r>
-            <a:r>
-              <a:rPr sz="1400">
-                <a:solidFill>
-                  <a:srgbClr val="444F66"/>
-                </a:solidFill>
-                <a:latin typeface="Calibri"/>
-              </a:rPr>
-              <a:t>Evento injetado aceito com HTTP 202 e visível como alarme crítico no portal.</a:t>
-            </a:r>
-          </a:p>
-          <a:p>
-            <a:pPr>
-              <a:lnSpc>
-                <a:spcPct val="120000"/>
-              </a:lnSpc>
-              <a:spcAft>
-                <a:spcPts val="1000"/>
-              </a:spcAft>
-            </a:pPr>
-            <a:r>
-              <a:rPr sz="1400" b="1">
-                <a:solidFill>
-                  <a:srgbClr val="3F5B8C"/>
-                </a:solidFill>
-                <a:latin typeface="Calibri"/>
-              </a:rPr>
-              <a:t>•   </a:t>
-            </a:r>
-            <a:r>
-              <a:rPr sz="1400" b="1">
-                <a:solidFill>
-                  <a:srgbClr val="1F2A44"/>
-                </a:solidFill>
-                <a:latin typeface="Calibri"/>
-              </a:rPr>
-              <a:t>A1. </a:t>
-            </a:r>
-            <a:r>
-              <a:rPr sz="1400">
-                <a:solidFill>
-                  <a:srgbClr val="444F66"/>
-                </a:solidFill>
-                <a:latin typeface="Calibri"/>
-              </a:rPr>
-              <a:t>Política criada (201), confirmada no Near-RT RIC e removida (204).</a:t>
-            </a:r>
-          </a:p>
-          <a:p>
-            <a:pPr>
-              <a:lnSpc>
-                <a:spcPct val="120000"/>
-              </a:lnSpc>
-              <a:spcAft>
-                <a:spcPts val="1000"/>
-              </a:spcAft>
-            </a:pPr>
-            <a:r>
-              <a:rPr sz="1400" b="1">
-                <a:solidFill>
-                  <a:srgbClr val="3F5B8C"/>
-                </a:solidFill>
-                <a:latin typeface="Calibri"/>
-              </a:rPr>
-              <a:t>•   </a:t>
-            </a:r>
-            <a:r>
-              <a:rPr sz="1400" b="1">
-                <a:solidFill>
-                  <a:srgbClr val="1F2A44"/>
-                </a:solidFill>
-                <a:latin typeface="Calibri"/>
-              </a:rPr>
-              <a:t>Ciclo de vida. </a:t>
-            </a:r>
-            <a:r>
-              <a:rPr sz="1400">
-                <a:solidFill>
-                  <a:srgbClr val="444F66"/>
-                </a:solidFill>
-                <a:latin typeface="Calibri"/>
-              </a:rPr>
-              <a:t>Parada derruba o mountpoint O1; reinício restabelece por registro automático.</a:t>
-            </a:r>
-          </a:p>
-        </p:txBody>
-      </p:sp>
-      <p:sp>
-        <p:nvSpPr>
-          <p:cNvPr id="8" name="TextBox 7"/>
-          <p:cNvSpPr txBox="1"/>
-          <p:nvPr/>
-        </p:nvSpPr>
-        <p:spPr>
-          <a:xfrm>
-            <a:off x="548640" y="4846320"/>
-            <a:ext cx="11064240" cy="502920"/>
-          </a:xfrm>
-          <a:prstGeom prst="rect">
-            <a:avLst/>
-          </a:prstGeom>
-          <a:noFill/>
-        </p:spPr>
-        <p:txBody>
-          <a:bodyPr wrap="square" anchor="t" lIns="0" rIns="0" tIns="0" bIns="0">
-            <a:spAutoFit/>
-          </a:bodyPr>
-          <a:lstStyle/>
-          <a:p>
-            <a:pPr algn="l">
-              <a:lnSpc>
-                <a:spcPct val="100000"/>
-              </a:lnSpc>
-              <a:spcAft>
-                <a:spcPts val="400"/>
-              </a:spcAft>
-            </a:pPr>
-            <a:r>
-              <a:rPr sz="1300" b="0">
-                <a:solidFill>
-                  <a:srgbClr val="444F66"/>
-                </a:solidFill>
-                <a:latin typeface="Calibri"/>
-              </a:rPr>
               <a:t>Além do roteiro, 87 testes automatizados sobre o portal — 60 de API e 27 de interface num navegador real, sem simulação de dependências.</a:t>
             </a:r>
           </a:p>
@@ -6759,7 +6507,7 @@
       </p:sp>
       <p:sp>
         <p:nvSpPr>
-          <p:cNvPr id="9" name="Rounded Rectangle 8"/>
+          <p:cNvPr id="8" name="Rounded Rectangle 7"/>
           <p:cNvSpPr/>
           <p:nvPr/>
         </p:nvSpPr>
@@ -6803,7 +6551,7 @@
       </p:sp>
       <p:sp>
         <p:nvSpPr>
-          <p:cNvPr id="10" name="TextBox 9"/>
+          <p:cNvPr id="9" name="TextBox 8"/>
           <p:cNvSpPr txBox="1"/>
           <p:nvPr/>
         </p:nvSpPr>
@@ -6845,7 +6593,7 @@
       </p:sp>
       <p:sp>
         <p:nvSpPr>
-          <p:cNvPr id="11" name="TextBox 10"/>
+          <p:cNvPr id="10" name="TextBox 9"/>
           <p:cNvSpPr txBox="1"/>
           <p:nvPr/>
         </p:nvSpPr>
@@ -7004,7 +6752,7 @@
         <p:spPr>
           <a:xfrm>
             <a:off x="457200" y="6492240"/>
-            <a:ext cx="5943600" cy="274320"/>
+            <a:ext cx="8229600" cy="274320"/>
           </a:xfrm>
           <a:prstGeom prst="rect">
             <a:avLst/>
@@ -7045,8 +6793,8 @@
         </p:nvSpPr>
         <p:spPr>
           <a:xfrm>
-            <a:off x="7589520" y="6492240"/>
-            <a:ext cx="3566160" cy="274320"/>
+            <a:off x="11274552" y="6492240"/>
+            <a:ext cx="457200" cy="274320"/>
           </a:xfrm>
           <a:prstGeom prst="rect">
             <a:avLst/>
@@ -7074,48 +6822,6 @@
                 </a:solidFill>
                 <a:latin typeface="Calibri"/>
               </a:rPr>
-              <a:t>Apresenta: Felipe Bartholo Favilla</a:t>
-            </a:r>
-          </a:p>
-        </p:txBody>
-      </p:sp>
-      <p:sp>
-        <p:nvSpPr>
-          <p:cNvPr id="6" name="TextBox 5"/>
-          <p:cNvSpPr txBox="1"/>
-          <p:nvPr/>
-        </p:nvSpPr>
-        <p:spPr>
-          <a:xfrm>
-            <a:off x="11274552" y="6492240"/>
-            <a:ext cx="457200" cy="274320"/>
-          </a:xfrm>
-          <a:prstGeom prst="rect">
-            <a:avLst/>
-          </a:prstGeom>
-          <a:noFill/>
-        </p:spPr>
-        <p:txBody>
-          <a:bodyPr wrap="square" anchor="t" lIns="0" rIns="0" tIns="0" bIns="0">
-            <a:spAutoFit/>
-          </a:bodyPr>
-          <a:lstStyle/>
-          <a:p>
-            <a:pPr algn="r">
-              <a:lnSpc>
-                <a:spcPct val="100000"/>
-              </a:lnSpc>
-              <a:spcAft>
-                <a:spcPts val="400"/>
-              </a:spcAft>
-            </a:pPr>
-            <a:r>
-              <a:rPr sz="900" b="0">
-                <a:solidFill>
-                  <a:srgbClr val="5C6B84"/>
-                </a:solidFill>
-                <a:latin typeface="Calibri"/>
-              </a:rPr>
               <a:t>15</a:t>
             </a:r>
           </a:p>
@@ -7123,7 +6829,7 @@
       </p:sp>
       <p:graphicFrame>
         <p:nvGraphicFramePr>
-          <p:cNvPr id="7" name="Table 6"/>
+          <p:cNvPr id="6" name="Table 5"/>
           <p:cNvGraphicFramePr>
             <a:graphicFrameLocks noGrp="1"/>
           </p:cNvGraphicFramePr>
@@ -7626,7 +7332,7 @@
       </p:graphicFrame>
       <p:sp>
         <p:nvSpPr>
-          <p:cNvPr id="8" name="Rounded Rectangle 7"/>
+          <p:cNvPr id="7" name="Rounded Rectangle 6"/>
           <p:cNvSpPr/>
           <p:nvPr/>
         </p:nvSpPr>
@@ -7670,7 +7376,7 @@
       </p:sp>
       <p:sp>
         <p:nvSpPr>
-          <p:cNvPr id="9" name="TextBox 8"/>
+          <p:cNvPr id="8" name="TextBox 7"/>
           <p:cNvSpPr txBox="1"/>
           <p:nvPr/>
         </p:nvSpPr>
@@ -7712,7 +7418,7 @@
       </p:sp>
       <p:sp>
         <p:nvSpPr>
-          <p:cNvPr id="10" name="TextBox 9"/>
+          <p:cNvPr id="9" name="TextBox 8"/>
           <p:cNvSpPr txBox="1"/>
           <p:nvPr/>
         </p:nvSpPr>
@@ -7871,7 +7577,7 @@
         <p:spPr>
           <a:xfrm>
             <a:off x="457200" y="6492240"/>
-            <a:ext cx="5943600" cy="274320"/>
+            <a:ext cx="8229600" cy="274320"/>
           </a:xfrm>
           <a:prstGeom prst="rect">
             <a:avLst/>
@@ -7912,8 +7618,8 @@
         </p:nvSpPr>
         <p:spPr>
           <a:xfrm>
-            <a:off x="7589520" y="6492240"/>
-            <a:ext cx="3566160" cy="274320"/>
+            <a:off x="11274552" y="6492240"/>
+            <a:ext cx="457200" cy="274320"/>
           </a:xfrm>
           <a:prstGeom prst="rect">
             <a:avLst/>
@@ -7941,48 +7647,6 @@
                 </a:solidFill>
                 <a:latin typeface="Calibri"/>
               </a:rPr>
-              <a:t>Apresenta: Felipe Bartholo Favilla</a:t>
-            </a:r>
-          </a:p>
-        </p:txBody>
-      </p:sp>
-      <p:sp>
-        <p:nvSpPr>
-          <p:cNvPr id="6" name="TextBox 5"/>
-          <p:cNvSpPr txBox="1"/>
-          <p:nvPr/>
-        </p:nvSpPr>
-        <p:spPr>
-          <a:xfrm>
-            <a:off x="11274552" y="6492240"/>
-            <a:ext cx="457200" cy="274320"/>
-          </a:xfrm>
-          <a:prstGeom prst="rect">
-            <a:avLst/>
-          </a:prstGeom>
-          <a:noFill/>
-        </p:spPr>
-        <p:txBody>
-          <a:bodyPr wrap="square" anchor="t" lIns="0" rIns="0" tIns="0" bIns="0">
-            <a:spAutoFit/>
-          </a:bodyPr>
-          <a:lstStyle/>
-          <a:p>
-            <a:pPr algn="r">
-              <a:lnSpc>
-                <a:spcPct val="100000"/>
-              </a:lnSpc>
-              <a:spcAft>
-                <a:spcPts val="400"/>
-              </a:spcAft>
-            </a:pPr>
-            <a:r>
-              <a:rPr sz="900" b="0">
-                <a:solidFill>
-                  <a:srgbClr val="5C6B84"/>
-                </a:solidFill>
-                <a:latin typeface="Calibri"/>
-              </a:rPr>
               <a:t>16</a:t>
             </a:r>
           </a:p>
@@ -7990,7 +7654,7 @@
       </p:sp>
       <p:sp>
         <p:nvSpPr>
-          <p:cNvPr id="7" name="Rounded Rectangle 6"/>
+          <p:cNvPr id="6" name="Rounded Rectangle 5"/>
           <p:cNvSpPr/>
           <p:nvPr/>
         </p:nvSpPr>
@@ -8036,7 +7700,7 @@
       </p:sp>
       <p:sp>
         <p:nvSpPr>
-          <p:cNvPr id="8" name="Rounded Rectangle 7"/>
+          <p:cNvPr id="7" name="Rounded Rectangle 6"/>
           <p:cNvSpPr/>
           <p:nvPr/>
         </p:nvSpPr>
@@ -8091,7 +7755,7 @@
       </p:sp>
       <p:sp>
         <p:nvSpPr>
-          <p:cNvPr id="9" name="TextBox 8"/>
+          <p:cNvPr id="8" name="TextBox 7"/>
           <p:cNvSpPr txBox="1"/>
           <p:nvPr/>
         </p:nvSpPr>
@@ -8133,7 +7797,7 @@
       </p:sp>
       <p:sp>
         <p:nvSpPr>
-          <p:cNvPr id="10" name="TextBox 9"/>
+          <p:cNvPr id="9" name="TextBox 8"/>
           <p:cNvSpPr txBox="1"/>
           <p:nvPr/>
         </p:nvSpPr>
@@ -8175,7 +7839,7 @@
       </p:sp>
       <p:sp>
         <p:nvSpPr>
-          <p:cNvPr id="11" name="Rounded Rectangle 10"/>
+          <p:cNvPr id="10" name="Rounded Rectangle 9"/>
           <p:cNvSpPr/>
           <p:nvPr/>
         </p:nvSpPr>
@@ -8221,7 +7885,7 @@
       </p:sp>
       <p:sp>
         <p:nvSpPr>
-          <p:cNvPr id="12" name="Rounded Rectangle 11"/>
+          <p:cNvPr id="11" name="Rounded Rectangle 10"/>
           <p:cNvSpPr/>
           <p:nvPr/>
         </p:nvSpPr>
@@ -8276,7 +7940,7 @@
       </p:sp>
       <p:sp>
         <p:nvSpPr>
-          <p:cNvPr id="13" name="TextBox 12"/>
+          <p:cNvPr id="12" name="TextBox 11"/>
           <p:cNvSpPr txBox="1"/>
           <p:nvPr/>
         </p:nvSpPr>
@@ -8318,7 +7982,7 @@
       </p:sp>
       <p:sp>
         <p:nvSpPr>
-          <p:cNvPr id="14" name="TextBox 13"/>
+          <p:cNvPr id="13" name="TextBox 12"/>
           <p:cNvSpPr txBox="1"/>
           <p:nvPr/>
         </p:nvSpPr>
@@ -8360,7 +8024,7 @@
       </p:sp>
       <p:sp>
         <p:nvSpPr>
-          <p:cNvPr id="15" name="Rounded Rectangle 14"/>
+          <p:cNvPr id="14" name="Rounded Rectangle 13"/>
           <p:cNvSpPr/>
           <p:nvPr/>
         </p:nvSpPr>
@@ -8406,7 +8070,7 @@
       </p:sp>
       <p:sp>
         <p:nvSpPr>
-          <p:cNvPr id="16" name="Rounded Rectangle 15"/>
+          <p:cNvPr id="15" name="Rounded Rectangle 14"/>
           <p:cNvSpPr/>
           <p:nvPr/>
         </p:nvSpPr>
@@ -8461,7 +8125,7 @@
       </p:sp>
       <p:sp>
         <p:nvSpPr>
-          <p:cNvPr id="17" name="TextBox 16"/>
+          <p:cNvPr id="16" name="TextBox 15"/>
           <p:cNvSpPr txBox="1"/>
           <p:nvPr/>
         </p:nvSpPr>
@@ -8503,7 +8167,7 @@
       </p:sp>
       <p:sp>
         <p:nvSpPr>
-          <p:cNvPr id="18" name="TextBox 17"/>
+          <p:cNvPr id="17" name="TextBox 16"/>
           <p:cNvSpPr txBox="1"/>
           <p:nvPr/>
         </p:nvSpPr>
@@ -8538,14 +8202,14 @@
                 </a:solidFill>
                 <a:latin typeface="Calibri"/>
               </a:rPr>
-              <a:t>Os quatro problemas encontrados eram de montagem, não de função. É neles que o tempo de uma implantação real se concentra.</a:t>
-            </a:r>
-          </a:p>
-        </p:txBody>
-      </p:sp>
-      <p:sp>
-        <p:nvSpPr>
-          <p:cNvPr id="19" name="Rounded Rectangle 18"/>
+              <a:t>Os quatro problemas encontrados eram de montagem, não de função. É neles que o tempo de uma implementação real se concentra.</a:t>
+            </a:r>
+          </a:p>
+        </p:txBody>
+      </p:sp>
+      <p:sp>
+        <p:nvSpPr>
+          <p:cNvPr id="18" name="Rounded Rectangle 17"/>
           <p:cNvSpPr/>
           <p:nvPr/>
         </p:nvSpPr>
@@ -8589,7 +8253,7 @@
       </p:sp>
       <p:sp>
         <p:nvSpPr>
-          <p:cNvPr id="20" name="TextBox 19"/>
+          <p:cNvPr id="19" name="TextBox 18"/>
           <p:cNvSpPr txBox="1"/>
           <p:nvPr/>
         </p:nvSpPr>
@@ -8631,7 +8295,7 @@
       </p:sp>
       <p:sp>
         <p:nvSpPr>
-          <p:cNvPr id="21" name="TextBox 20"/>
+          <p:cNvPr id="20" name="TextBox 19"/>
           <p:cNvSpPr txBox="1"/>
           <p:nvPr/>
         </p:nvSpPr>
@@ -8666,7 +8330,7 @@
                 </a:solidFill>
                 <a:latin typeface="Calibri"/>
               </a:rPr>
-              <a:t>Pilha completa, portal de operação, scripts de verificação e relatório publicados em github.com/felipefavilla/smo-openran</a:t>
+              <a:t>Pilha completa, portal de operação, scripts de verificação e relatório — tudo o que é necessário para reproduzir o resultado.</a:t>
             </a:r>
           </a:p>
         </p:txBody>
@@ -8776,7 +8440,7 @@
                 </a:solidFill>
                 <a:latin typeface="Calibri"/>
               </a:rPr>
-              <a:t>Fontes oficiais e repositório do trabalho</a:t>
+              <a:t>Fontes oficiais consultadas</a:t>
             </a:r>
           </a:p>
         </p:txBody>
@@ -8790,7 +8454,7 @@
         <p:spPr>
           <a:xfrm>
             <a:off x="457200" y="6492240"/>
-            <a:ext cx="5943600" cy="274320"/>
+            <a:ext cx="8229600" cy="274320"/>
           </a:xfrm>
           <a:prstGeom prst="rect">
             <a:avLst/>
@@ -8831,8 +8495,8 @@
         </p:nvSpPr>
         <p:spPr>
           <a:xfrm>
-            <a:off x="7589520" y="6492240"/>
-            <a:ext cx="3566160" cy="274320"/>
+            <a:off x="11274552" y="6492240"/>
+            <a:ext cx="457200" cy="274320"/>
           </a:xfrm>
           <a:prstGeom prst="rect">
             <a:avLst/>
@@ -8860,7 +8524,7 @@
                 </a:solidFill>
                 <a:latin typeface="Calibri"/>
               </a:rPr>
-              <a:t>Apresenta: Felipe Bartholo Favilla</a:t>
+              <a:t>17</a:t>
             </a:r>
           </a:p>
         </p:txBody>
@@ -8868,48 +8532,6 @@
       <p:sp>
         <p:nvSpPr>
           <p:cNvPr id="6" name="TextBox 5"/>
-          <p:cNvSpPr txBox="1"/>
-          <p:nvPr/>
-        </p:nvSpPr>
-        <p:spPr>
-          <a:xfrm>
-            <a:off x="11274552" y="6492240"/>
-            <a:ext cx="457200" cy="274320"/>
-          </a:xfrm>
-          <a:prstGeom prst="rect">
-            <a:avLst/>
-          </a:prstGeom>
-          <a:noFill/>
-        </p:spPr>
-        <p:txBody>
-          <a:bodyPr wrap="square" anchor="t" lIns="0" rIns="0" tIns="0" bIns="0">
-            <a:spAutoFit/>
-          </a:bodyPr>
-          <a:lstStyle/>
-          <a:p>
-            <a:pPr algn="r">
-              <a:lnSpc>
-                <a:spcPct val="100000"/>
-              </a:lnSpc>
-              <a:spcAft>
-                <a:spcPts val="400"/>
-              </a:spcAft>
-            </a:pPr>
-            <a:r>
-              <a:rPr sz="900" b="0">
-                <a:solidFill>
-                  <a:srgbClr val="5C6B84"/>
-                </a:solidFill>
-                <a:latin typeface="Calibri"/>
-              </a:rPr>
-              <a:t>17</a:t>
-            </a:r>
-          </a:p>
-        </p:txBody>
-      </p:sp>
-      <p:sp>
-        <p:nvSpPr>
-          <p:cNvPr id="7" name="TextBox 6"/>
           <p:cNvSpPr txBox="1"/>
           <p:nvPr/>
         </p:nvSpPr>
@@ -9094,162 +8716,6 @@
                 <a:latin typeface="Calibri"/>
               </a:rPr>
               <a:t>3GPP. TS 28.552 — Management and orchestration; 5G performance measurements.</a:t>
-            </a:r>
-          </a:p>
-          <a:p>
-            <a:pPr>
-              <a:lnSpc>
-                <a:spcPct val="120000"/>
-              </a:lnSpc>
-              <a:spcAft>
-                <a:spcPts val="1000"/>
-              </a:spcAft>
-            </a:pPr>
-            <a:r>
-              <a:rPr sz="1300" b="1">
-                <a:solidFill>
-                  <a:srgbClr val="3F5B8C"/>
-                </a:solidFill>
-                <a:latin typeface="Calibri"/>
-              </a:rPr>
-              <a:t>•   </a:t>
-            </a:r>
-            <a:r>
-              <a:rPr sz="1300">
-                <a:solidFill>
-                  <a:srgbClr val="444F66"/>
-                </a:solidFill>
-                <a:latin typeface="Calibri"/>
-              </a:rPr>
-              <a:t>FAVILLA, F. B. et al. Relatório — Parte 1: pesquisa, comparação e seleção de plataforma de SMO. CPQD, 2026.</a:t>
-            </a:r>
-          </a:p>
-        </p:txBody>
-      </p:sp>
-      <p:sp>
-        <p:nvSpPr>
-          <p:cNvPr id="8" name="Rounded Rectangle 7"/>
-          <p:cNvSpPr/>
-          <p:nvPr/>
-        </p:nvSpPr>
-        <p:spPr>
-          <a:xfrm>
-            <a:off x="548640" y="4892040"/>
-            <a:ext cx="11064240" cy="1005840"/>
-          </a:xfrm>
-          <a:prstGeom prst="roundRect">
-            <a:avLst>
-              <a:gd name="adj" fmla="val 6000"/>
-            </a:avLst>
-          </a:prstGeom>
-          <a:solidFill>
-            <a:srgbClr val="1F2A44"/>
-          </a:solidFill>
-          <a:ln>
-            <a:noFill/>
-          </a:ln>
-          <a:effectLst/>
-        </p:spPr>
-        <p:style>
-          <a:lnRef idx="1">
-            <a:schemeClr val="accent1"/>
-          </a:lnRef>
-          <a:fillRef idx="3">
-            <a:schemeClr val="accent1"/>
-          </a:fillRef>
-          <a:effectRef idx="2">
-            <a:schemeClr val="accent1"/>
-          </a:effectRef>
-          <a:fontRef idx="minor">
-            <a:schemeClr val="lt1"/>
-          </a:fontRef>
-        </p:style>
-        <p:txBody>
-          <a:bodyPr rtlCol="0" anchor="ctr"/>
-          <a:lstStyle/>
-          <a:p/>
-        </p:txBody>
-      </p:sp>
-      <p:sp>
-        <p:nvSpPr>
-          <p:cNvPr id="9" name="TextBox 8"/>
-          <p:cNvSpPr txBox="1"/>
-          <p:nvPr/>
-        </p:nvSpPr>
-        <p:spPr>
-          <a:xfrm>
-            <a:off x="914400" y="5074920"/>
-            <a:ext cx="2743200" cy="640080"/>
-          </a:xfrm>
-          <a:prstGeom prst="rect">
-            <a:avLst/>
-          </a:prstGeom>
-          <a:noFill/>
-        </p:spPr>
-        <p:txBody>
-          <a:bodyPr wrap="square" anchor="ctr" lIns="0" rIns="0" tIns="0" bIns="0">
-            <a:spAutoFit/>
-          </a:bodyPr>
-          <a:lstStyle/>
-          <a:p>
-            <a:pPr algn="l">
-              <a:lnSpc>
-                <a:spcPct val="100000"/>
-              </a:lnSpc>
-              <a:spcAft>
-                <a:spcPts val="400"/>
-              </a:spcAft>
-            </a:pPr>
-            <a:r>
-              <a:rPr sz="1400" b="1">
-                <a:solidFill>
-                  <a:srgbClr val="FFFFFF"/>
-                </a:solidFill>
-                <a:latin typeface="Calibri"/>
-              </a:rPr>
-              <a:t>Repositório:</a:t>
-            </a:r>
-          </a:p>
-        </p:txBody>
-      </p:sp>
-      <p:sp>
-        <p:nvSpPr>
-          <p:cNvPr id="10" name="TextBox 9"/>
-          <p:cNvSpPr txBox="1"/>
-          <p:nvPr/>
-        </p:nvSpPr>
-        <p:spPr>
-          <a:xfrm>
-            <a:off x="3657600" y="5074920"/>
-            <a:ext cx="7680960" cy="640080"/>
-          </a:xfrm>
-          <a:prstGeom prst="rect">
-            <a:avLst/>
-          </a:prstGeom>
-          <a:noFill/>
-        </p:spPr>
-        <p:txBody>
-          <a:bodyPr wrap="square" anchor="ctr" lIns="0" rIns="0" tIns="0" bIns="0">
-            <a:spAutoFit/>
-          </a:bodyPr>
-          <a:lstStyle/>
-          <a:p>
-            <a:pPr algn="l">
-              <a:lnSpc>
-                <a:spcPct val="115000"/>
-              </a:lnSpc>
-              <a:spcAft>
-                <a:spcPts val="400"/>
-              </a:spcAft>
-            </a:pPr>
-            <a:r>
-              <a:rPr sz="1200" b="0">
-                <a:solidFill>
-                  <a:srgbClr val="DDE3EE"/>
-                </a:solidFill>
-                <a:latin typeface="Calibri"/>
-              </a:rPr>
-              <a:t>github.com/felipefavilla/smo-openran</a:t>
             </a:r>
           </a:p>
         </p:txBody>
@@ -9373,7 +8839,7 @@
         <p:spPr>
           <a:xfrm>
             <a:off x="457200" y="6492240"/>
-            <a:ext cx="5943600" cy="274320"/>
+            <a:ext cx="8229600" cy="274320"/>
           </a:xfrm>
           <a:prstGeom prst="rect">
             <a:avLst/>
@@ -9414,8 +8880,8 @@
         </p:nvSpPr>
         <p:spPr>
           <a:xfrm>
-            <a:off x="7589520" y="6492240"/>
-            <a:ext cx="3566160" cy="274320"/>
+            <a:off x="11274552" y="6492240"/>
+            <a:ext cx="457200" cy="274320"/>
           </a:xfrm>
           <a:prstGeom prst="rect">
             <a:avLst/>
@@ -9443,48 +8909,6 @@
                 </a:solidFill>
                 <a:latin typeface="Calibri"/>
               </a:rPr>
-              <a:t>Apresenta: Felipe Bartholo Favilla</a:t>
-            </a:r>
-          </a:p>
-        </p:txBody>
-      </p:sp>
-      <p:sp>
-        <p:nvSpPr>
-          <p:cNvPr id="6" name="TextBox 5"/>
-          <p:cNvSpPr txBox="1"/>
-          <p:nvPr/>
-        </p:nvSpPr>
-        <p:spPr>
-          <a:xfrm>
-            <a:off x="11274552" y="6492240"/>
-            <a:ext cx="457200" cy="274320"/>
-          </a:xfrm>
-          <a:prstGeom prst="rect">
-            <a:avLst/>
-          </a:prstGeom>
-          <a:noFill/>
-        </p:spPr>
-        <p:txBody>
-          <a:bodyPr wrap="square" anchor="t" lIns="0" rIns="0" tIns="0" bIns="0">
-            <a:spAutoFit/>
-          </a:bodyPr>
-          <a:lstStyle/>
-          <a:p>
-            <a:pPr algn="r">
-              <a:lnSpc>
-                <a:spcPct val="100000"/>
-              </a:lnSpc>
-              <a:spcAft>
-                <a:spcPts val="400"/>
-              </a:spcAft>
-            </a:pPr>
-            <a:r>
-              <a:rPr sz="900" b="0">
-                <a:solidFill>
-                  <a:srgbClr val="5C6B84"/>
-                </a:solidFill>
-                <a:latin typeface="Calibri"/>
-              </a:rPr>
               <a:t>2</a:t>
             </a:r>
           </a:p>
@@ -9492,7 +8916,7 @@
       </p:sp>
       <p:sp>
         <p:nvSpPr>
-          <p:cNvPr id="7" name="Rounded Rectangle 6"/>
+          <p:cNvPr id="6" name="Rounded Rectangle 5"/>
           <p:cNvSpPr/>
           <p:nvPr/>
         </p:nvSpPr>
@@ -9538,7 +8962,7 @@
       </p:sp>
       <p:sp>
         <p:nvSpPr>
-          <p:cNvPr id="8" name="Rounded Rectangle 7"/>
+          <p:cNvPr id="7" name="Rounded Rectangle 6"/>
           <p:cNvSpPr/>
           <p:nvPr/>
         </p:nvSpPr>
@@ -9593,7 +9017,7 @@
       </p:sp>
       <p:sp>
         <p:nvSpPr>
-          <p:cNvPr id="9" name="TextBox 8"/>
+          <p:cNvPr id="8" name="TextBox 7"/>
           <p:cNvSpPr txBox="1"/>
           <p:nvPr/>
         </p:nvSpPr>
@@ -9635,7 +9059,7 @@
       </p:sp>
       <p:sp>
         <p:nvSpPr>
-          <p:cNvPr id="10" name="TextBox 9"/>
+          <p:cNvPr id="9" name="TextBox 8"/>
           <p:cNvSpPr txBox="1"/>
           <p:nvPr/>
         </p:nvSpPr>
@@ -9677,7 +9101,7 @@
       </p:sp>
       <p:sp>
         <p:nvSpPr>
-          <p:cNvPr id="11" name="Rounded Rectangle 10"/>
+          <p:cNvPr id="10" name="Rounded Rectangle 9"/>
           <p:cNvSpPr/>
           <p:nvPr/>
         </p:nvSpPr>
@@ -9723,7 +9147,7 @@
       </p:sp>
       <p:sp>
         <p:nvSpPr>
-          <p:cNvPr id="12" name="Rounded Rectangle 11"/>
+          <p:cNvPr id="11" name="Rounded Rectangle 10"/>
           <p:cNvSpPr/>
           <p:nvPr/>
         </p:nvSpPr>
@@ -9778,7 +9202,7 @@
       </p:sp>
       <p:sp>
         <p:nvSpPr>
-          <p:cNvPr id="13" name="TextBox 12"/>
+          <p:cNvPr id="12" name="TextBox 11"/>
           <p:cNvSpPr txBox="1"/>
           <p:nvPr/>
         </p:nvSpPr>
@@ -9820,7 +9244,7 @@
       </p:sp>
       <p:sp>
         <p:nvSpPr>
-          <p:cNvPr id="14" name="TextBox 13"/>
+          <p:cNvPr id="13" name="TextBox 12"/>
           <p:cNvSpPr txBox="1"/>
           <p:nvPr/>
         </p:nvSpPr>
@@ -9862,7 +9286,7 @@
       </p:sp>
       <p:sp>
         <p:nvSpPr>
-          <p:cNvPr id="15" name="Rounded Rectangle 14"/>
+          <p:cNvPr id="14" name="Rounded Rectangle 13"/>
           <p:cNvSpPr/>
           <p:nvPr/>
         </p:nvSpPr>
@@ -9908,7 +9332,7 @@
       </p:sp>
       <p:sp>
         <p:nvSpPr>
-          <p:cNvPr id="16" name="Rounded Rectangle 15"/>
+          <p:cNvPr id="15" name="Rounded Rectangle 14"/>
           <p:cNvSpPr/>
           <p:nvPr/>
         </p:nvSpPr>
@@ -9963,7 +9387,7 @@
       </p:sp>
       <p:sp>
         <p:nvSpPr>
-          <p:cNvPr id="17" name="TextBox 16"/>
+          <p:cNvPr id="16" name="TextBox 15"/>
           <p:cNvSpPr txBox="1"/>
           <p:nvPr/>
         </p:nvSpPr>
@@ -10005,7 +9429,7 @@
       </p:sp>
       <p:sp>
         <p:nvSpPr>
-          <p:cNvPr id="18" name="TextBox 17"/>
+          <p:cNvPr id="17" name="TextBox 16"/>
           <p:cNvSpPr txBox="1"/>
           <p:nvPr/>
         </p:nvSpPr>
@@ -10047,7 +9471,7 @@
       </p:sp>
       <p:sp>
         <p:nvSpPr>
-          <p:cNvPr id="19" name="Rounded Rectangle 18"/>
+          <p:cNvPr id="18" name="Rounded Rectangle 17"/>
           <p:cNvSpPr/>
           <p:nvPr/>
         </p:nvSpPr>
@@ -10091,7 +9515,7 @@
       </p:sp>
       <p:sp>
         <p:nvSpPr>
-          <p:cNvPr id="20" name="TextBox 19"/>
+          <p:cNvPr id="19" name="TextBox 18"/>
           <p:cNvSpPr txBox="1"/>
           <p:nvPr/>
         </p:nvSpPr>
@@ -10133,7 +9557,7 @@
       </p:sp>
       <p:sp>
         <p:nvSpPr>
-          <p:cNvPr id="21" name="TextBox 20"/>
+          <p:cNvPr id="20" name="TextBox 19"/>
           <p:cNvSpPr txBox="1"/>
           <p:nvPr/>
         </p:nvSpPr>
@@ -10236,7 +9660,7 @@
                 </a:solidFill>
                 <a:latin typeface="Cambria"/>
               </a:rPr>
-              <a:t>O que foi implantado</a:t>
+              <a:t>O que foi implementado</a:t>
             </a:r>
           </a:p>
         </p:txBody>
@@ -10292,7 +9716,7 @@
         <p:spPr>
           <a:xfrm>
             <a:off x="457200" y="6492240"/>
-            <a:ext cx="5943600" cy="274320"/>
+            <a:ext cx="8229600" cy="274320"/>
           </a:xfrm>
           <a:prstGeom prst="rect">
             <a:avLst/>
@@ -10333,8 +9757,8 @@
         </p:nvSpPr>
         <p:spPr>
           <a:xfrm>
-            <a:off x="7589520" y="6492240"/>
-            <a:ext cx="3566160" cy="274320"/>
+            <a:off x="11274552" y="6492240"/>
+            <a:ext cx="457200" cy="274320"/>
           </a:xfrm>
           <a:prstGeom prst="rect">
             <a:avLst/>
@@ -10362,48 +9786,6 @@
                 </a:solidFill>
                 <a:latin typeface="Calibri"/>
               </a:rPr>
-              <a:t>Apresenta: Felipe Bartholo Favilla</a:t>
-            </a:r>
-          </a:p>
-        </p:txBody>
-      </p:sp>
-      <p:sp>
-        <p:nvSpPr>
-          <p:cNvPr id="6" name="TextBox 5"/>
-          <p:cNvSpPr txBox="1"/>
-          <p:nvPr/>
-        </p:nvSpPr>
-        <p:spPr>
-          <a:xfrm>
-            <a:off x="11274552" y="6492240"/>
-            <a:ext cx="457200" cy="274320"/>
-          </a:xfrm>
-          <a:prstGeom prst="rect">
-            <a:avLst/>
-          </a:prstGeom>
-          <a:noFill/>
-        </p:spPr>
-        <p:txBody>
-          <a:bodyPr wrap="square" anchor="t" lIns="0" rIns="0" tIns="0" bIns="0">
-            <a:spAutoFit/>
-          </a:bodyPr>
-          <a:lstStyle/>
-          <a:p>
-            <a:pPr algn="r">
-              <a:lnSpc>
-                <a:spcPct val="100000"/>
-              </a:lnSpc>
-              <a:spcAft>
-                <a:spcPts val="400"/>
-              </a:spcAft>
-            </a:pPr>
-            <a:r>
-              <a:rPr sz="900" b="0">
-                <a:solidFill>
-                  <a:srgbClr val="5C6B84"/>
-                </a:solidFill>
-                <a:latin typeface="Calibri"/>
-              </a:rPr>
               <a:t>3</a:t>
             </a:r>
           </a:p>
@@ -10411,7 +9793,7 @@
       </p:sp>
       <p:graphicFrame>
         <p:nvGraphicFramePr>
-          <p:cNvPr id="7" name="Table 6"/>
+          <p:cNvPr id="6" name="Table 5"/>
           <p:cNvGraphicFramePr>
             <a:graphicFrameLocks noGrp="1"/>
           </p:cNvGraphicFramePr>
@@ -10982,7 +10364,7 @@
       </p:graphicFrame>
       <p:sp>
         <p:nvSpPr>
-          <p:cNvPr id="8" name="Rounded Rectangle 7"/>
+          <p:cNvPr id="7" name="Rounded Rectangle 6"/>
           <p:cNvSpPr/>
           <p:nvPr/>
         </p:nvSpPr>
@@ -11026,7 +10408,7 @@
       </p:sp>
       <p:sp>
         <p:nvSpPr>
-          <p:cNvPr id="9" name="TextBox 8"/>
+          <p:cNvPr id="8" name="TextBox 7"/>
           <p:cNvSpPr txBox="1"/>
           <p:nvPr/>
         </p:nvSpPr>
@@ -11068,7 +10450,7 @@
       </p:sp>
       <p:sp>
         <p:nvSpPr>
-          <p:cNvPr id="10" name="TextBox 9"/>
+          <p:cNvPr id="9" name="TextBox 8"/>
           <p:cNvSpPr txBox="1"/>
           <p:nvPr/>
         </p:nvSpPr>
@@ -11171,7 +10553,7 @@
                 </a:solidFill>
                 <a:latin typeface="Cambria"/>
               </a:rPr>
-              <a:t>Arquitetura implantada</a:t>
+              <a:t>Arquitetura implementada</a:t>
             </a:r>
           </a:p>
         </p:txBody>
@@ -11227,7 +10609,7 @@
         <p:spPr>
           <a:xfrm>
             <a:off x="457200" y="6492240"/>
-            <a:ext cx="5943600" cy="274320"/>
+            <a:ext cx="8229600" cy="274320"/>
           </a:xfrm>
           <a:prstGeom prst="rect">
             <a:avLst/>
@@ -11268,8 +10650,8 @@
         </p:nvSpPr>
         <p:spPr>
           <a:xfrm>
-            <a:off x="7589520" y="6492240"/>
-            <a:ext cx="3566160" cy="274320"/>
+            <a:off x="11274552" y="6492240"/>
+            <a:ext cx="457200" cy="274320"/>
           </a:xfrm>
           <a:prstGeom prst="rect">
             <a:avLst/>
@@ -11297,48 +10679,6 @@
                 </a:solidFill>
                 <a:latin typeface="Calibri"/>
               </a:rPr>
-              <a:t>Apresenta: Felipe Bartholo Favilla</a:t>
-            </a:r>
-          </a:p>
-        </p:txBody>
-      </p:sp>
-      <p:sp>
-        <p:nvSpPr>
-          <p:cNvPr id="6" name="TextBox 5"/>
-          <p:cNvSpPr txBox="1"/>
-          <p:nvPr/>
-        </p:nvSpPr>
-        <p:spPr>
-          <a:xfrm>
-            <a:off x="11274552" y="6492240"/>
-            <a:ext cx="457200" cy="274320"/>
-          </a:xfrm>
-          <a:prstGeom prst="rect">
-            <a:avLst/>
-          </a:prstGeom>
-          <a:noFill/>
-        </p:spPr>
-        <p:txBody>
-          <a:bodyPr wrap="square" anchor="t" lIns="0" rIns="0" tIns="0" bIns="0">
-            <a:spAutoFit/>
-          </a:bodyPr>
-          <a:lstStyle/>
-          <a:p>
-            <a:pPr algn="r">
-              <a:lnSpc>
-                <a:spcPct val="100000"/>
-              </a:lnSpc>
-              <a:spcAft>
-                <a:spcPts val="400"/>
-              </a:spcAft>
-            </a:pPr>
-            <a:r>
-              <a:rPr sz="900" b="0">
-                <a:solidFill>
-                  <a:srgbClr val="5C6B84"/>
-                </a:solidFill>
-                <a:latin typeface="Calibri"/>
-              </a:rPr>
               <a:t>4</a:t>
             </a:r>
           </a:p>
@@ -11346,7 +10686,7 @@
       </p:sp>
       <p:sp>
         <p:nvSpPr>
-          <p:cNvPr id="7" name="Rounded Rectangle 6"/>
+          <p:cNvPr id="6" name="Rounded Rectangle 5"/>
           <p:cNvSpPr/>
           <p:nvPr/>
         </p:nvSpPr>
@@ -11392,7 +10732,7 @@
       </p:sp>
       <p:sp>
         <p:nvSpPr>
-          <p:cNvPr id="8" name="TextBox 7"/>
+          <p:cNvPr id="7" name="TextBox 6"/>
           <p:cNvSpPr txBox="1"/>
           <p:nvPr/>
         </p:nvSpPr>
@@ -11776,7 +11116,7 @@
       </p:sp>
       <p:sp>
         <p:nvSpPr>
-          <p:cNvPr id="9" name="TextBox 8"/>
+          <p:cNvPr id="8" name="TextBox 7"/>
           <p:cNvSpPr txBox="1"/>
           <p:nvPr/>
         </p:nvSpPr>
@@ -11935,7 +11275,7 @@
         <p:spPr>
           <a:xfrm>
             <a:off x="457200" y="6492240"/>
-            <a:ext cx="5943600" cy="274320"/>
+            <a:ext cx="8229600" cy="274320"/>
           </a:xfrm>
           <a:prstGeom prst="rect">
             <a:avLst/>
@@ -11976,8 +11316,8 @@
         </p:nvSpPr>
         <p:spPr>
           <a:xfrm>
-            <a:off x="7589520" y="6492240"/>
-            <a:ext cx="3566160" cy="274320"/>
+            <a:off x="11274552" y="6492240"/>
+            <a:ext cx="457200" cy="274320"/>
           </a:xfrm>
           <a:prstGeom prst="rect">
             <a:avLst/>
@@ -12005,7 +11345,7 @@
                 </a:solidFill>
                 <a:latin typeface="Calibri"/>
               </a:rPr>
-              <a:t>Apresenta: Felipe Bartholo Favilla</a:t>
+              <a:t>5</a:t>
             </a:r>
           </a:p>
         </p:txBody>
@@ -12013,48 +11353,6 @@
       <p:sp>
         <p:nvSpPr>
           <p:cNvPr id="6" name="TextBox 5"/>
-          <p:cNvSpPr txBox="1"/>
-          <p:nvPr/>
-        </p:nvSpPr>
-        <p:spPr>
-          <a:xfrm>
-            <a:off x="11274552" y="6492240"/>
-            <a:ext cx="457200" cy="274320"/>
-          </a:xfrm>
-          <a:prstGeom prst="rect">
-            <a:avLst/>
-          </a:prstGeom>
-          <a:noFill/>
-        </p:spPr>
-        <p:txBody>
-          <a:bodyPr wrap="square" anchor="t" lIns="0" rIns="0" tIns="0" bIns="0">
-            <a:spAutoFit/>
-          </a:bodyPr>
-          <a:lstStyle/>
-          <a:p>
-            <a:pPr algn="r">
-              <a:lnSpc>
-                <a:spcPct val="100000"/>
-              </a:lnSpc>
-              <a:spcAft>
-                <a:spcPts val="400"/>
-              </a:spcAft>
-            </a:pPr>
-            <a:r>
-              <a:rPr sz="900" b="0">
-                <a:solidFill>
-                  <a:srgbClr val="5C6B84"/>
-                </a:solidFill>
-                <a:latin typeface="Calibri"/>
-              </a:rPr>
-              <a:t>5</a:t>
-            </a:r>
-          </a:p>
-        </p:txBody>
-      </p:sp>
-      <p:sp>
-        <p:nvSpPr>
-          <p:cNvPr id="7" name="TextBox 6"/>
           <p:cNvSpPr txBox="1"/>
           <p:nvPr/>
         </p:nvSpPr>
@@ -12262,7 +11560,7 @@
       </p:sp>
       <p:sp>
         <p:nvSpPr>
-          <p:cNvPr id="8" name="Rounded Rectangle 7"/>
+          <p:cNvPr id="7" name="Rounded Rectangle 6"/>
           <p:cNvSpPr/>
           <p:nvPr/>
         </p:nvSpPr>
@@ -12306,7 +11604,7 @@
       </p:sp>
       <p:sp>
         <p:nvSpPr>
-          <p:cNvPr id="9" name="TextBox 8"/>
+          <p:cNvPr id="8" name="TextBox 7"/>
           <p:cNvSpPr txBox="1"/>
           <p:nvPr/>
         </p:nvSpPr>
@@ -12348,7 +11646,7 @@
       </p:sp>
       <p:sp>
         <p:nvSpPr>
-          <p:cNvPr id="10" name="TextBox 9"/>
+          <p:cNvPr id="9" name="TextBox 8"/>
           <p:cNvSpPr txBox="1"/>
           <p:nvPr/>
         </p:nvSpPr>
@@ -12507,7 +11805,7 @@
         <p:spPr>
           <a:xfrm>
             <a:off x="457200" y="6492240"/>
-            <a:ext cx="5943600" cy="274320"/>
+            <a:ext cx="8229600" cy="274320"/>
           </a:xfrm>
           <a:prstGeom prst="rect">
             <a:avLst/>
@@ -12548,8 +11846,8 @@
         </p:nvSpPr>
         <p:spPr>
           <a:xfrm>
-            <a:off x="7589520" y="6492240"/>
-            <a:ext cx="3566160" cy="274320"/>
+            <a:off x="11274552" y="6492240"/>
+            <a:ext cx="457200" cy="274320"/>
           </a:xfrm>
           <a:prstGeom prst="rect">
             <a:avLst/>
@@ -12577,48 +11875,6 @@
                 </a:solidFill>
                 <a:latin typeface="Calibri"/>
               </a:rPr>
-              <a:t>Apresenta: Felipe Bartholo Favilla</a:t>
-            </a:r>
-          </a:p>
-        </p:txBody>
-      </p:sp>
-      <p:sp>
-        <p:nvSpPr>
-          <p:cNvPr id="6" name="TextBox 5"/>
-          <p:cNvSpPr txBox="1"/>
-          <p:nvPr/>
-        </p:nvSpPr>
-        <p:spPr>
-          <a:xfrm>
-            <a:off x="11274552" y="6492240"/>
-            <a:ext cx="457200" cy="274320"/>
-          </a:xfrm>
-          <a:prstGeom prst="rect">
-            <a:avLst/>
-          </a:prstGeom>
-          <a:noFill/>
-        </p:spPr>
-        <p:txBody>
-          <a:bodyPr wrap="square" anchor="t" lIns="0" rIns="0" tIns="0" bIns="0">
-            <a:spAutoFit/>
-          </a:bodyPr>
-          <a:lstStyle/>
-          <a:p>
-            <a:pPr algn="r">
-              <a:lnSpc>
-                <a:spcPct val="100000"/>
-              </a:lnSpc>
-              <a:spcAft>
-                <a:spcPts val="400"/>
-              </a:spcAft>
-            </a:pPr>
-            <a:r>
-              <a:rPr sz="900" b="0">
-                <a:solidFill>
-                  <a:srgbClr val="5C6B84"/>
-                </a:solidFill>
-                <a:latin typeface="Calibri"/>
-              </a:rPr>
               <a:t>6</a:t>
             </a:r>
           </a:p>
@@ -12626,7 +11882,7 @@
       </p:sp>
       <p:sp>
         <p:nvSpPr>
-          <p:cNvPr id="7" name="Rounded Rectangle 6"/>
+          <p:cNvPr id="6" name="Rounded Rectangle 5"/>
           <p:cNvSpPr/>
           <p:nvPr/>
         </p:nvSpPr>
@@ -12672,7 +11928,7 @@
       </p:sp>
       <p:sp>
         <p:nvSpPr>
-          <p:cNvPr id="8" name="Rounded Rectangle 7"/>
+          <p:cNvPr id="7" name="Rounded Rectangle 6"/>
           <p:cNvSpPr/>
           <p:nvPr/>
         </p:nvSpPr>
@@ -12727,7 +11983,7 @@
       </p:sp>
       <p:sp>
         <p:nvSpPr>
-          <p:cNvPr id="9" name="TextBox 8"/>
+          <p:cNvPr id="8" name="TextBox 7"/>
           <p:cNvSpPr txBox="1"/>
           <p:nvPr/>
         </p:nvSpPr>
@@ -12769,7 +12025,7 @@
       </p:sp>
       <p:sp>
         <p:nvSpPr>
-          <p:cNvPr id="10" name="TextBox 9"/>
+          <p:cNvPr id="9" name="TextBox 8"/>
           <p:cNvSpPr txBox="1"/>
           <p:nvPr/>
         </p:nvSpPr>
@@ -12811,7 +12067,7 @@
       </p:sp>
       <p:sp>
         <p:nvSpPr>
-          <p:cNvPr id="11" name="Rounded Rectangle 10"/>
+          <p:cNvPr id="10" name="Rounded Rectangle 9"/>
           <p:cNvSpPr/>
           <p:nvPr/>
         </p:nvSpPr>
@@ -12857,7 +12113,7 @@
       </p:sp>
       <p:sp>
         <p:nvSpPr>
-          <p:cNvPr id="12" name="Rounded Rectangle 11"/>
+          <p:cNvPr id="11" name="Rounded Rectangle 10"/>
           <p:cNvSpPr/>
           <p:nvPr/>
         </p:nvSpPr>
@@ -12912,7 +12168,7 @@
       </p:sp>
       <p:sp>
         <p:nvSpPr>
-          <p:cNvPr id="13" name="TextBox 12"/>
+          <p:cNvPr id="12" name="TextBox 11"/>
           <p:cNvSpPr txBox="1"/>
           <p:nvPr/>
         </p:nvSpPr>
@@ -12954,7 +12210,7 @@
       </p:sp>
       <p:sp>
         <p:nvSpPr>
-          <p:cNvPr id="14" name="TextBox 13"/>
+          <p:cNvPr id="13" name="TextBox 12"/>
           <p:cNvSpPr txBox="1"/>
           <p:nvPr/>
         </p:nvSpPr>
@@ -12996,7 +12252,7 @@
       </p:sp>
       <p:sp>
         <p:nvSpPr>
-          <p:cNvPr id="15" name="Rounded Rectangle 14"/>
+          <p:cNvPr id="14" name="Rounded Rectangle 13"/>
           <p:cNvSpPr/>
           <p:nvPr/>
         </p:nvSpPr>
@@ -13042,7 +12298,7 @@
       </p:sp>
       <p:sp>
         <p:nvSpPr>
-          <p:cNvPr id="16" name="Rounded Rectangle 15"/>
+          <p:cNvPr id="15" name="Rounded Rectangle 14"/>
           <p:cNvSpPr/>
           <p:nvPr/>
         </p:nvSpPr>
@@ -13097,7 +12353,7 @@
       </p:sp>
       <p:sp>
         <p:nvSpPr>
-          <p:cNvPr id="17" name="TextBox 16"/>
+          <p:cNvPr id="16" name="TextBox 15"/>
           <p:cNvSpPr txBox="1"/>
           <p:nvPr/>
         </p:nvSpPr>
@@ -13139,7 +12395,7 @@
       </p:sp>
       <p:sp>
         <p:nvSpPr>
-          <p:cNvPr id="18" name="TextBox 17"/>
+          <p:cNvPr id="17" name="TextBox 16"/>
           <p:cNvSpPr txBox="1"/>
           <p:nvPr/>
         </p:nvSpPr>
@@ -13181,7 +12437,7 @@
       </p:sp>
       <p:sp>
         <p:nvSpPr>
-          <p:cNvPr id="19" name="Rounded Rectangle 18"/>
+          <p:cNvPr id="18" name="Rounded Rectangle 17"/>
           <p:cNvSpPr/>
           <p:nvPr/>
         </p:nvSpPr>
@@ -13225,7 +12481,7 @@
       </p:sp>
       <p:sp>
         <p:nvSpPr>
-          <p:cNvPr id="20" name="TextBox 19"/>
+          <p:cNvPr id="19" name="TextBox 18"/>
           <p:cNvSpPr txBox="1"/>
           <p:nvPr/>
         </p:nvSpPr>
@@ -13267,7 +12523,7 @@
       </p:sp>
       <p:sp>
         <p:nvSpPr>
-          <p:cNvPr id="21" name="TextBox 20"/>
+          <p:cNvPr id="20" name="TextBox 19"/>
           <p:cNvSpPr txBox="1"/>
           <p:nvPr/>
         </p:nvSpPr>
@@ -13426,7 +12682,7 @@
         <p:spPr>
           <a:xfrm>
             <a:off x="457200" y="6492240"/>
-            <a:ext cx="5943600" cy="274320"/>
+            <a:ext cx="8229600" cy="274320"/>
           </a:xfrm>
           <a:prstGeom prst="rect">
             <a:avLst/>
@@ -13467,8 +12723,8 @@
         </p:nvSpPr>
         <p:spPr>
           <a:xfrm>
-            <a:off x="7589520" y="6492240"/>
-            <a:ext cx="3566160" cy="274320"/>
+            <a:off x="11274552" y="6492240"/>
+            <a:ext cx="457200" cy="274320"/>
           </a:xfrm>
           <a:prstGeom prst="rect">
             <a:avLst/>
@@ -13496,48 +12752,6 @@
                 </a:solidFill>
                 <a:latin typeface="Calibri"/>
               </a:rPr>
-              <a:t>Apresenta: Felipe Bartholo Favilla</a:t>
-            </a:r>
-          </a:p>
-        </p:txBody>
-      </p:sp>
-      <p:sp>
-        <p:nvSpPr>
-          <p:cNvPr id="6" name="TextBox 5"/>
-          <p:cNvSpPr txBox="1"/>
-          <p:nvPr/>
-        </p:nvSpPr>
-        <p:spPr>
-          <a:xfrm>
-            <a:off x="11274552" y="6492240"/>
-            <a:ext cx="457200" cy="274320"/>
-          </a:xfrm>
-          <a:prstGeom prst="rect">
-            <a:avLst/>
-          </a:prstGeom>
-          <a:noFill/>
-        </p:spPr>
-        <p:txBody>
-          <a:bodyPr wrap="square" anchor="t" lIns="0" rIns="0" tIns="0" bIns="0">
-            <a:spAutoFit/>
-          </a:bodyPr>
-          <a:lstStyle/>
-          <a:p>
-            <a:pPr algn="r">
-              <a:lnSpc>
-                <a:spcPct val="100000"/>
-              </a:lnSpc>
-              <a:spcAft>
-                <a:spcPts val="400"/>
-              </a:spcAft>
-            </a:pPr>
-            <a:r>
-              <a:rPr sz="900" b="0">
-                <a:solidFill>
-                  <a:srgbClr val="5C6B84"/>
-                </a:solidFill>
-                <a:latin typeface="Calibri"/>
-              </a:rPr>
               <a:t>7</a:t>
             </a:r>
           </a:p>
@@ -13545,7 +12759,7 @@
       </p:sp>
       <p:graphicFrame>
         <p:nvGraphicFramePr>
-          <p:cNvPr id="7" name="Table 6"/>
+          <p:cNvPr id="6" name="Table 5"/>
           <p:cNvGraphicFramePr>
             <a:graphicFrameLocks noGrp="1"/>
           </p:cNvGraphicFramePr>
@@ -13801,7 +13015,7 @@
       </p:graphicFrame>
       <p:sp>
         <p:nvSpPr>
-          <p:cNvPr id="8" name="TextBox 7"/>
+          <p:cNvPr id="7" name="TextBox 6"/>
           <p:cNvSpPr txBox="1"/>
           <p:nvPr/>
         </p:nvSpPr>
@@ -13843,7 +13057,7 @@
       </p:sp>
       <p:sp>
         <p:nvSpPr>
-          <p:cNvPr id="9" name="Rounded Rectangle 8"/>
+          <p:cNvPr id="8" name="Rounded Rectangle 7"/>
           <p:cNvSpPr/>
           <p:nvPr/>
         </p:nvSpPr>
@@ -13887,7 +13101,7 @@
       </p:sp>
       <p:sp>
         <p:nvSpPr>
-          <p:cNvPr id="10" name="TextBox 9"/>
+          <p:cNvPr id="9" name="TextBox 8"/>
           <p:cNvSpPr txBox="1"/>
           <p:nvPr/>
         </p:nvSpPr>
@@ -13929,7 +13143,7 @@
       </p:sp>
       <p:sp>
         <p:nvSpPr>
-          <p:cNvPr id="11" name="TextBox 10"/>
+          <p:cNvPr id="10" name="TextBox 9"/>
           <p:cNvSpPr txBox="1"/>
           <p:nvPr/>
         </p:nvSpPr>
@@ -14088,7 +13302,7 @@
         <p:spPr>
           <a:xfrm>
             <a:off x="457200" y="6492240"/>
-            <a:ext cx="5943600" cy="274320"/>
+            <a:ext cx="8229600" cy="274320"/>
           </a:xfrm>
           <a:prstGeom prst="rect">
             <a:avLst/>
@@ -14129,8 +13343,8 @@
         </p:nvSpPr>
         <p:spPr>
           <a:xfrm>
-            <a:off x="7589520" y="6492240"/>
-            <a:ext cx="3566160" cy="274320"/>
+            <a:off x="11274552" y="6492240"/>
+            <a:ext cx="457200" cy="274320"/>
           </a:xfrm>
           <a:prstGeom prst="rect">
             <a:avLst/>
@@ -14158,48 +13372,6 @@
                 </a:solidFill>
                 <a:latin typeface="Calibri"/>
               </a:rPr>
-              <a:t>Apresenta: Felipe Bartholo Favilla</a:t>
-            </a:r>
-          </a:p>
-        </p:txBody>
-      </p:sp>
-      <p:sp>
-        <p:nvSpPr>
-          <p:cNvPr id="6" name="TextBox 5"/>
-          <p:cNvSpPr txBox="1"/>
-          <p:nvPr/>
-        </p:nvSpPr>
-        <p:spPr>
-          <a:xfrm>
-            <a:off x="11274552" y="6492240"/>
-            <a:ext cx="457200" cy="274320"/>
-          </a:xfrm>
-          <a:prstGeom prst="rect">
-            <a:avLst/>
-          </a:prstGeom>
-          <a:noFill/>
-        </p:spPr>
-        <p:txBody>
-          <a:bodyPr wrap="square" anchor="t" lIns="0" rIns="0" tIns="0" bIns="0">
-            <a:spAutoFit/>
-          </a:bodyPr>
-          <a:lstStyle/>
-          <a:p>
-            <a:pPr algn="r">
-              <a:lnSpc>
-                <a:spcPct val="100000"/>
-              </a:lnSpc>
-              <a:spcAft>
-                <a:spcPts val="400"/>
-              </a:spcAft>
-            </a:pPr>
-            <a:r>
-              <a:rPr sz="900" b="0">
-                <a:solidFill>
-                  <a:srgbClr val="5C6B84"/>
-                </a:solidFill>
-                <a:latin typeface="Calibri"/>
-              </a:rPr>
               <a:t>8</a:t>
             </a:r>
           </a:p>
@@ -14207,7 +13379,7 @@
       </p:sp>
       <p:graphicFrame>
         <p:nvGraphicFramePr>
-          <p:cNvPr id="7" name="Table 6"/>
+          <p:cNvPr id="6" name="Table 5"/>
           <p:cNvGraphicFramePr>
             <a:graphicFrameLocks noGrp="1"/>
           </p:cNvGraphicFramePr>
@@ -14642,7 +13814,7 @@
       </p:graphicFrame>
       <p:sp>
         <p:nvSpPr>
-          <p:cNvPr id="8" name="Rounded Rectangle 7"/>
+          <p:cNvPr id="7" name="Rounded Rectangle 6"/>
           <p:cNvSpPr/>
           <p:nvPr/>
         </p:nvSpPr>
@@ -14686,7 +13858,7 @@
       </p:sp>
       <p:sp>
         <p:nvSpPr>
-          <p:cNvPr id="9" name="TextBox 8"/>
+          <p:cNvPr id="8" name="TextBox 7"/>
           <p:cNvSpPr txBox="1"/>
           <p:nvPr/>
         </p:nvSpPr>
@@ -14728,7 +13900,7 @@
       </p:sp>
       <p:sp>
         <p:nvSpPr>
-          <p:cNvPr id="10" name="TextBox 9"/>
+          <p:cNvPr id="9" name="TextBox 8"/>
           <p:cNvSpPr txBox="1"/>
           <p:nvPr/>
         </p:nvSpPr>
@@ -14770,7 +13942,7 @@
       </p:sp>
       <p:sp>
         <p:nvSpPr>
-          <p:cNvPr id="11" name="TextBox 10"/>
+          <p:cNvPr id="10" name="TextBox 9"/>
           <p:cNvSpPr txBox="1"/>
           <p:nvPr/>
         </p:nvSpPr>
@@ -14929,7 +14101,7 @@
         <p:spPr>
           <a:xfrm>
             <a:off x="457200" y="6492240"/>
-            <a:ext cx="5943600" cy="274320"/>
+            <a:ext cx="8229600" cy="274320"/>
           </a:xfrm>
           <a:prstGeom prst="rect">
             <a:avLst/>
@@ -14970,8 +14142,8 @@
         </p:nvSpPr>
         <p:spPr>
           <a:xfrm>
-            <a:off x="7589520" y="6492240"/>
-            <a:ext cx="3566160" cy="274320"/>
+            <a:off x="11274552" y="6492240"/>
+            <a:ext cx="457200" cy="274320"/>
           </a:xfrm>
           <a:prstGeom prst="rect">
             <a:avLst/>
@@ -14999,48 +14171,6 @@
                 </a:solidFill>
                 <a:latin typeface="Calibri"/>
               </a:rPr>
-              <a:t>Apresenta: Felipe Bartholo Favilla</a:t>
-            </a:r>
-          </a:p>
-        </p:txBody>
-      </p:sp>
-      <p:sp>
-        <p:nvSpPr>
-          <p:cNvPr id="6" name="TextBox 5"/>
-          <p:cNvSpPr txBox="1"/>
-          <p:nvPr/>
-        </p:nvSpPr>
-        <p:spPr>
-          <a:xfrm>
-            <a:off x="11274552" y="6492240"/>
-            <a:ext cx="457200" cy="274320"/>
-          </a:xfrm>
-          <a:prstGeom prst="rect">
-            <a:avLst/>
-          </a:prstGeom>
-          <a:noFill/>
-        </p:spPr>
-        <p:txBody>
-          <a:bodyPr wrap="square" anchor="t" lIns="0" rIns="0" tIns="0" bIns="0">
-            <a:spAutoFit/>
-          </a:bodyPr>
-          <a:lstStyle/>
-          <a:p>
-            <a:pPr algn="r">
-              <a:lnSpc>
-                <a:spcPct val="100000"/>
-              </a:lnSpc>
-              <a:spcAft>
-                <a:spcPts val="400"/>
-              </a:spcAft>
-            </a:pPr>
-            <a:r>
-              <a:rPr sz="900" b="0">
-                <a:solidFill>
-                  <a:srgbClr val="5C6B84"/>
-                </a:solidFill>
-                <a:latin typeface="Calibri"/>
-              </a:rPr>
               <a:t>9</a:t>
             </a:r>
           </a:p>
@@ -15048,7 +14178,7 @@
       </p:sp>
       <p:pic>
         <p:nvPicPr>
-          <p:cNvPr id="7" name="Picture 6" descr="falhas-light.png"/>
+          <p:cNvPr id="6" name="Picture 5" descr="falhas-light.png"/>
           <p:cNvPicPr>
             <a:picLocks noChangeAspect="1"/>
           </p:cNvPicPr>
@@ -15077,7 +14207,7 @@
       </p:pic>
       <p:pic>
         <p:nvPicPr>
-          <p:cNvPr id="8" name="Picture 7" descr="desempenho-light.png"/>
+          <p:cNvPr id="7" name="Picture 6" descr="desempenho-light.png"/>
           <p:cNvPicPr>
             <a:picLocks noChangeAspect="1"/>
           </p:cNvPicPr>
@@ -15106,7 +14236,7 @@
       </p:pic>
       <p:sp>
         <p:nvSpPr>
-          <p:cNvPr id="9" name="TextBox 8"/>
+          <p:cNvPr id="8" name="TextBox 7"/>
           <p:cNvSpPr txBox="1"/>
           <p:nvPr/>
         </p:nvSpPr>

</xml_diff>